<commit_message>
Update final report and presentation documents
Replaced documentation files with the latest versions of the final project report and presentation.
</commit_message>
<xml_diff>
--- a/docs/docs/PGDDE_Capstone_Healthcare_Analytics_Pipeline_IITJ.pptx
+++ b/docs/docs/PGDDE_Capstone_Healthcare_Analytics_Pipeline_IITJ.pptx
@@ -4,18 +4,24 @@
   <p:sldMasterIdLst>
     <p:sldMasterId id="2147483648" r:id="rId1"/>
   </p:sldMasterIdLst>
+  <p:notesMasterIdLst>
+    <p:notesMasterId r:id="rId16"/>
+  </p:notesMasterIdLst>
   <p:sldIdLst>
     <p:sldId id="256" r:id="rId2"/>
     <p:sldId id="257" r:id="rId3"/>
     <p:sldId id="258" r:id="rId4"/>
     <p:sldId id="259" r:id="rId5"/>
     <p:sldId id="260" r:id="rId6"/>
-    <p:sldId id="261" r:id="rId7"/>
-    <p:sldId id="262" r:id="rId8"/>
-    <p:sldId id="263" r:id="rId9"/>
-    <p:sldId id="264" r:id="rId10"/>
-    <p:sldId id="265" r:id="rId11"/>
-    <p:sldId id="266" r:id="rId12"/>
+    <p:sldId id="267" r:id="rId7"/>
+    <p:sldId id="261" r:id="rId8"/>
+    <p:sldId id="268" r:id="rId9"/>
+    <p:sldId id="262" r:id="rId10"/>
+    <p:sldId id="263" r:id="rId11"/>
+    <p:sldId id="264" r:id="rId12"/>
+    <p:sldId id="269" r:id="rId13"/>
+    <p:sldId id="265" r:id="rId14"/>
+    <p:sldId id="266" r:id="rId15"/>
   </p:sldIdLst>
   <p:sldSz cx="12192000" cy="6858000"/>
   <p:notesSz cx="6858000" cy="9144000"/>
@@ -122,6 +128,440 @@
 </p:presentation>
 </file>
 
+<file path=ppt/notesMasters/notesMaster1.xml><?xml version="1.0" encoding="utf-8"?>
+<p:notesMaster xmlns:a="http://schemas.openxmlformats.org/drawingml/2006/main" xmlns:r="http://schemas.openxmlformats.org/officeDocument/2006/relationships" xmlns:p="http://schemas.openxmlformats.org/presentationml/2006/main">
+  <p:cSld>
+    <p:bg>
+      <p:bgRef idx="1001">
+        <a:schemeClr val="bg1"/>
+      </p:bgRef>
+    </p:bg>
+    <p:spTree>
+      <p:nvGrpSpPr>
+        <p:cNvPr id="1" name=""/>
+        <p:cNvGrpSpPr/>
+        <p:nvPr/>
+      </p:nvGrpSpPr>
+      <p:grpSpPr>
+        <a:xfrm>
+          <a:off x="0" y="0"/>
+          <a:ext cx="0" cy="0"/>
+          <a:chOff x="0" y="0"/>
+          <a:chExt cx="0" cy="0"/>
+        </a:xfrm>
+      </p:grpSpPr>
+      <p:sp>
+        <p:nvSpPr>
+          <p:cNvPr id="2" name="Header Placeholder 1"/>
+          <p:cNvSpPr>
+            <a:spLocks noGrp="1"/>
+          </p:cNvSpPr>
+          <p:nvPr>
+            <p:ph type="hdr" sz="quarter"/>
+          </p:nvPr>
+        </p:nvSpPr>
+        <p:spPr>
+          <a:xfrm>
+            <a:off x="0" y="0"/>
+            <a:ext cx="2971800" cy="458788"/>
+          </a:xfrm>
+          <a:prstGeom prst="rect">
+            <a:avLst/>
+          </a:prstGeom>
+        </p:spPr>
+        <p:txBody>
+          <a:bodyPr vert="horz" lIns="91440" tIns="45720" rIns="91440" bIns="45720" rtlCol="0"/>
+          <a:lstStyle>
+            <a:lvl1pPr algn="l">
+              <a:defRPr sz="1200"/>
+            </a:lvl1pPr>
+          </a:lstStyle>
+          <a:p>
+            <a:endParaRPr lang="en-GB"/>
+          </a:p>
+        </p:txBody>
+      </p:sp>
+      <p:sp>
+        <p:nvSpPr>
+          <p:cNvPr id="3" name="Date Placeholder 2"/>
+          <p:cNvSpPr>
+            <a:spLocks noGrp="1"/>
+          </p:cNvSpPr>
+          <p:nvPr>
+            <p:ph type="dt" idx="1"/>
+          </p:nvPr>
+        </p:nvSpPr>
+        <p:spPr>
+          <a:xfrm>
+            <a:off x="3884613" y="0"/>
+            <a:ext cx="2971800" cy="458788"/>
+          </a:xfrm>
+          <a:prstGeom prst="rect">
+            <a:avLst/>
+          </a:prstGeom>
+        </p:spPr>
+        <p:txBody>
+          <a:bodyPr vert="horz" lIns="91440" tIns="45720" rIns="91440" bIns="45720" rtlCol="0"/>
+          <a:lstStyle>
+            <a:lvl1pPr algn="r">
+              <a:defRPr sz="1200"/>
+            </a:lvl1pPr>
+          </a:lstStyle>
+          <a:p>
+            <a:fld id="{6CAD6177-CAEF-4E70-8DEE-78C553712586}" type="datetimeFigureOut">
+              <a:rPr lang="en-GB" smtClean="0"/>
+              <a:t>31/05/2026</a:t>
+            </a:fld>
+            <a:endParaRPr lang="en-GB"/>
+          </a:p>
+        </p:txBody>
+      </p:sp>
+      <p:sp>
+        <p:nvSpPr>
+          <p:cNvPr id="4" name="Slide Image Placeholder 3"/>
+          <p:cNvSpPr>
+            <a:spLocks noGrp="1" noRot="1" noChangeAspect="1"/>
+          </p:cNvSpPr>
+          <p:nvPr>
+            <p:ph type="sldImg" idx="2"/>
+          </p:nvPr>
+        </p:nvSpPr>
+        <p:spPr>
+          <a:xfrm>
+            <a:off x="685800" y="1143000"/>
+            <a:ext cx="5486400" cy="3086100"/>
+          </a:xfrm>
+          <a:prstGeom prst="rect">
+            <a:avLst/>
+          </a:prstGeom>
+          <a:noFill/>
+          <a:ln w="12700">
+            <a:solidFill>
+              <a:prstClr val="black"/>
+            </a:solidFill>
+          </a:ln>
+        </p:spPr>
+        <p:txBody>
+          <a:bodyPr vert="horz" lIns="91440" tIns="45720" rIns="91440" bIns="45720" rtlCol="0" anchor="ctr"/>
+          <a:lstStyle/>
+          <a:p>
+            <a:endParaRPr lang="en-GB"/>
+          </a:p>
+        </p:txBody>
+      </p:sp>
+      <p:sp>
+        <p:nvSpPr>
+          <p:cNvPr id="5" name="Notes Placeholder 4"/>
+          <p:cNvSpPr>
+            <a:spLocks noGrp="1"/>
+          </p:cNvSpPr>
+          <p:nvPr>
+            <p:ph type="body" sz="quarter" idx="3"/>
+          </p:nvPr>
+        </p:nvSpPr>
+        <p:spPr>
+          <a:xfrm>
+            <a:off x="685800" y="4400550"/>
+            <a:ext cx="5486400" cy="3600450"/>
+          </a:xfrm>
+          <a:prstGeom prst="rect">
+            <a:avLst/>
+          </a:prstGeom>
+        </p:spPr>
+        <p:txBody>
+          <a:bodyPr vert="horz" lIns="91440" tIns="45720" rIns="91440" bIns="45720" rtlCol="0"/>
+          <a:lstStyle/>
+          <a:p>
+            <a:pPr lvl="0"/>
+            <a:r>
+              <a:rPr lang="en-US"/>
+              <a:t>Click to edit Master text styles</a:t>
+            </a:r>
+          </a:p>
+          <a:p>
+            <a:pPr lvl="1"/>
+            <a:r>
+              <a:rPr lang="en-US"/>
+              <a:t>Second level</a:t>
+            </a:r>
+          </a:p>
+          <a:p>
+            <a:pPr lvl="2"/>
+            <a:r>
+              <a:rPr lang="en-US"/>
+              <a:t>Third level</a:t>
+            </a:r>
+          </a:p>
+          <a:p>
+            <a:pPr lvl="3"/>
+            <a:r>
+              <a:rPr lang="en-US"/>
+              <a:t>Fourth level</a:t>
+            </a:r>
+          </a:p>
+          <a:p>
+            <a:pPr lvl="4"/>
+            <a:r>
+              <a:rPr lang="en-US"/>
+              <a:t>Fifth level</a:t>
+            </a:r>
+            <a:endParaRPr lang="en-GB"/>
+          </a:p>
+        </p:txBody>
+      </p:sp>
+      <p:sp>
+        <p:nvSpPr>
+          <p:cNvPr id="6" name="Footer Placeholder 5"/>
+          <p:cNvSpPr>
+            <a:spLocks noGrp="1"/>
+          </p:cNvSpPr>
+          <p:nvPr>
+            <p:ph type="ftr" sz="quarter" idx="4"/>
+          </p:nvPr>
+        </p:nvSpPr>
+        <p:spPr>
+          <a:xfrm>
+            <a:off x="0" y="8685213"/>
+            <a:ext cx="2971800" cy="458787"/>
+          </a:xfrm>
+          <a:prstGeom prst="rect">
+            <a:avLst/>
+          </a:prstGeom>
+        </p:spPr>
+        <p:txBody>
+          <a:bodyPr vert="horz" lIns="91440" tIns="45720" rIns="91440" bIns="45720" rtlCol="0" anchor="b"/>
+          <a:lstStyle>
+            <a:lvl1pPr algn="l">
+              <a:defRPr sz="1200"/>
+            </a:lvl1pPr>
+          </a:lstStyle>
+          <a:p>
+            <a:endParaRPr lang="en-GB"/>
+          </a:p>
+        </p:txBody>
+      </p:sp>
+      <p:sp>
+        <p:nvSpPr>
+          <p:cNvPr id="7" name="Slide Number Placeholder 6"/>
+          <p:cNvSpPr>
+            <a:spLocks noGrp="1"/>
+          </p:cNvSpPr>
+          <p:nvPr>
+            <p:ph type="sldNum" sz="quarter" idx="5"/>
+          </p:nvPr>
+        </p:nvSpPr>
+        <p:spPr>
+          <a:xfrm>
+            <a:off x="3884613" y="8685213"/>
+            <a:ext cx="2971800" cy="458787"/>
+          </a:xfrm>
+          <a:prstGeom prst="rect">
+            <a:avLst/>
+          </a:prstGeom>
+        </p:spPr>
+        <p:txBody>
+          <a:bodyPr vert="horz" lIns="91440" tIns="45720" rIns="91440" bIns="45720" rtlCol="0" anchor="b"/>
+          <a:lstStyle>
+            <a:lvl1pPr algn="r">
+              <a:defRPr sz="1200"/>
+            </a:lvl1pPr>
+          </a:lstStyle>
+          <a:p>
+            <a:fld id="{1CC3EDED-0833-4F63-A997-9302F708B90C}" type="slidenum">
+              <a:rPr lang="en-GB" smtClean="0"/>
+              <a:t>‹#›</a:t>
+            </a:fld>
+            <a:endParaRPr lang="en-GB"/>
+          </a:p>
+        </p:txBody>
+      </p:sp>
+    </p:spTree>
+    <p:extLst>
+      <p:ext uri="{BB962C8B-B14F-4D97-AF65-F5344CB8AC3E}">
+        <p14:creationId xmlns:p14="http://schemas.microsoft.com/office/powerpoint/2010/main" val="588181457"/>
+      </p:ext>
+    </p:extLst>
+  </p:cSld>
+  <p:clrMap bg1="lt1" tx1="dk1" bg2="lt2" tx2="dk2" accent1="accent1" accent2="accent2" accent3="accent3" accent4="accent4" accent5="accent5" accent6="accent6" hlink="hlink" folHlink="folHlink"/>
+  <p:notesStyle>
+    <a:lvl1pPr marL="0" algn="l" defTabSz="914400" rtl="0" eaLnBrk="1" latinLnBrk="0" hangingPunct="1">
+      <a:defRPr sz="1200" kern="1200">
+        <a:solidFill>
+          <a:schemeClr val="tx1"/>
+        </a:solidFill>
+        <a:latin typeface="+mn-lt"/>
+        <a:ea typeface="+mn-ea"/>
+        <a:cs typeface="+mn-cs"/>
+      </a:defRPr>
+    </a:lvl1pPr>
+    <a:lvl2pPr marL="457200" algn="l" defTabSz="914400" rtl="0" eaLnBrk="1" latinLnBrk="0" hangingPunct="1">
+      <a:defRPr sz="1200" kern="1200">
+        <a:solidFill>
+          <a:schemeClr val="tx1"/>
+        </a:solidFill>
+        <a:latin typeface="+mn-lt"/>
+        <a:ea typeface="+mn-ea"/>
+        <a:cs typeface="+mn-cs"/>
+      </a:defRPr>
+    </a:lvl2pPr>
+    <a:lvl3pPr marL="914400" algn="l" defTabSz="914400" rtl="0" eaLnBrk="1" latinLnBrk="0" hangingPunct="1">
+      <a:defRPr sz="1200" kern="1200">
+        <a:solidFill>
+          <a:schemeClr val="tx1"/>
+        </a:solidFill>
+        <a:latin typeface="+mn-lt"/>
+        <a:ea typeface="+mn-ea"/>
+        <a:cs typeface="+mn-cs"/>
+      </a:defRPr>
+    </a:lvl3pPr>
+    <a:lvl4pPr marL="1371600" algn="l" defTabSz="914400" rtl="0" eaLnBrk="1" latinLnBrk="0" hangingPunct="1">
+      <a:defRPr sz="1200" kern="1200">
+        <a:solidFill>
+          <a:schemeClr val="tx1"/>
+        </a:solidFill>
+        <a:latin typeface="+mn-lt"/>
+        <a:ea typeface="+mn-ea"/>
+        <a:cs typeface="+mn-cs"/>
+      </a:defRPr>
+    </a:lvl4pPr>
+    <a:lvl5pPr marL="1828800" algn="l" defTabSz="914400" rtl="0" eaLnBrk="1" latinLnBrk="0" hangingPunct="1">
+      <a:defRPr sz="1200" kern="1200">
+        <a:solidFill>
+          <a:schemeClr val="tx1"/>
+        </a:solidFill>
+        <a:latin typeface="+mn-lt"/>
+        <a:ea typeface="+mn-ea"/>
+        <a:cs typeface="+mn-cs"/>
+      </a:defRPr>
+    </a:lvl5pPr>
+    <a:lvl6pPr marL="2286000" algn="l" defTabSz="914400" rtl="0" eaLnBrk="1" latinLnBrk="0" hangingPunct="1">
+      <a:defRPr sz="1200" kern="1200">
+        <a:solidFill>
+          <a:schemeClr val="tx1"/>
+        </a:solidFill>
+        <a:latin typeface="+mn-lt"/>
+        <a:ea typeface="+mn-ea"/>
+        <a:cs typeface="+mn-cs"/>
+      </a:defRPr>
+    </a:lvl6pPr>
+    <a:lvl7pPr marL="2743200" algn="l" defTabSz="914400" rtl="0" eaLnBrk="1" latinLnBrk="0" hangingPunct="1">
+      <a:defRPr sz="1200" kern="1200">
+        <a:solidFill>
+          <a:schemeClr val="tx1"/>
+        </a:solidFill>
+        <a:latin typeface="+mn-lt"/>
+        <a:ea typeface="+mn-ea"/>
+        <a:cs typeface="+mn-cs"/>
+      </a:defRPr>
+    </a:lvl7pPr>
+    <a:lvl8pPr marL="3200400" algn="l" defTabSz="914400" rtl="0" eaLnBrk="1" latinLnBrk="0" hangingPunct="1">
+      <a:defRPr sz="1200" kern="1200">
+        <a:solidFill>
+          <a:schemeClr val="tx1"/>
+        </a:solidFill>
+        <a:latin typeface="+mn-lt"/>
+        <a:ea typeface="+mn-ea"/>
+        <a:cs typeface="+mn-cs"/>
+      </a:defRPr>
+    </a:lvl8pPr>
+    <a:lvl9pPr marL="3657600" algn="l" defTabSz="914400" rtl="0" eaLnBrk="1" latinLnBrk="0" hangingPunct="1">
+      <a:defRPr sz="1200" kern="1200">
+        <a:solidFill>
+          <a:schemeClr val="tx1"/>
+        </a:solidFill>
+        <a:latin typeface="+mn-lt"/>
+        <a:ea typeface="+mn-ea"/>
+        <a:cs typeface="+mn-cs"/>
+      </a:defRPr>
+    </a:lvl9pPr>
+  </p:notesStyle>
+</p:notesMaster>
+</file>
+
+<file path=ppt/notesSlides/notesSlide1.xml><?xml version="1.0" encoding="utf-8"?>
+<p:notes xmlns:a="http://schemas.openxmlformats.org/drawingml/2006/main" xmlns:r="http://schemas.openxmlformats.org/officeDocument/2006/relationships" xmlns:p="http://schemas.openxmlformats.org/presentationml/2006/main">
+  <p:cSld>
+    <p:spTree>
+      <p:nvGrpSpPr>
+        <p:cNvPr id="1" name=""/>
+        <p:cNvGrpSpPr/>
+        <p:nvPr/>
+      </p:nvGrpSpPr>
+      <p:grpSpPr>
+        <a:xfrm>
+          <a:off x="0" y="0"/>
+          <a:ext cx="0" cy="0"/>
+          <a:chOff x="0" y="0"/>
+          <a:chExt cx="0" cy="0"/>
+        </a:xfrm>
+      </p:grpSpPr>
+      <p:sp>
+        <p:nvSpPr>
+          <p:cNvPr id="2" name="Slide Image Placeholder 1"/>
+          <p:cNvSpPr>
+            <a:spLocks noGrp="1" noRot="1" noChangeAspect="1"/>
+          </p:cNvSpPr>
+          <p:nvPr>
+            <p:ph type="sldImg"/>
+          </p:nvPr>
+        </p:nvSpPr>
+        <p:spPr/>
+      </p:sp>
+      <p:sp>
+        <p:nvSpPr>
+          <p:cNvPr id="3" name="Notes Placeholder 2"/>
+          <p:cNvSpPr>
+            <a:spLocks noGrp="1"/>
+          </p:cNvSpPr>
+          <p:nvPr>
+            <p:ph type="body" idx="1"/>
+          </p:nvPr>
+        </p:nvSpPr>
+        <p:spPr/>
+        <p:txBody>
+          <a:bodyPr/>
+          <a:lstStyle/>
+          <a:p>
+            <a:endParaRPr lang="en-GB" dirty="0"/>
+          </a:p>
+        </p:txBody>
+      </p:sp>
+      <p:sp>
+        <p:nvSpPr>
+          <p:cNvPr id="4" name="Slide Number Placeholder 3"/>
+          <p:cNvSpPr>
+            <a:spLocks noGrp="1"/>
+          </p:cNvSpPr>
+          <p:nvPr>
+            <p:ph type="sldNum" sz="quarter" idx="5"/>
+          </p:nvPr>
+        </p:nvSpPr>
+        <p:spPr/>
+        <p:txBody>
+          <a:bodyPr/>
+          <a:lstStyle/>
+          <a:p>
+            <a:fld id="{1CC3EDED-0833-4F63-A997-9302F708B90C}" type="slidenum">
+              <a:rPr lang="en-GB" smtClean="0"/>
+              <a:t>11</a:t>
+            </a:fld>
+            <a:endParaRPr lang="en-GB"/>
+          </a:p>
+        </p:txBody>
+      </p:sp>
+    </p:spTree>
+    <p:extLst>
+      <p:ext uri="{BB962C8B-B14F-4D97-AF65-F5344CB8AC3E}">
+        <p14:creationId xmlns:p14="http://schemas.microsoft.com/office/powerpoint/2010/main" val="3354561894"/>
+      </p:ext>
+    </p:extLst>
+  </p:cSld>
+  <p:clrMapOvr>
+    <a:masterClrMapping/>
+  </p:clrMapOvr>
+</p:notes>
+</file>
+
 <file path=ppt/slideLayouts/slideLayout1.xml><?xml version="1.0" encoding="utf-8"?>
 <p:sldLayout xmlns:a="http://schemas.openxmlformats.org/drawingml/2006/main" xmlns:r="http://schemas.openxmlformats.org/officeDocument/2006/relationships" xmlns:p="http://schemas.openxmlformats.org/presentationml/2006/main" type="title" preserve="1">
   <p:cSld name="Title Slide">
@@ -271,7 +711,7 @@
           <a:p>
             <a:fld id="{8727B1B5-114F-462F-9F43-A96471EB3E77}" type="datetimeFigureOut">
               <a:rPr lang="en-GB" smtClean="0"/>
-              <a:t>29/05/2026</a:t>
+              <a:t>31/05/2026</a:t>
             </a:fld>
             <a:endParaRPr lang="en-GB"/>
           </a:p>
@@ -471,7 +911,7 @@
           <a:p>
             <a:fld id="{8727B1B5-114F-462F-9F43-A96471EB3E77}" type="datetimeFigureOut">
               <a:rPr lang="en-GB" smtClean="0"/>
-              <a:t>29/05/2026</a:t>
+              <a:t>31/05/2026</a:t>
             </a:fld>
             <a:endParaRPr lang="en-GB"/>
           </a:p>
@@ -681,7 +1121,7 @@
           <a:p>
             <a:fld id="{8727B1B5-114F-462F-9F43-A96471EB3E77}" type="datetimeFigureOut">
               <a:rPr lang="en-GB" smtClean="0"/>
-              <a:t>29/05/2026</a:t>
+              <a:t>31/05/2026</a:t>
             </a:fld>
             <a:endParaRPr lang="en-GB"/>
           </a:p>
@@ -881,7 +1321,7 @@
           <a:p>
             <a:fld id="{8727B1B5-114F-462F-9F43-A96471EB3E77}" type="datetimeFigureOut">
               <a:rPr lang="en-GB" smtClean="0"/>
-              <a:t>29/05/2026</a:t>
+              <a:t>31/05/2026</a:t>
             </a:fld>
             <a:endParaRPr lang="en-GB"/>
           </a:p>
@@ -1157,7 +1597,7 @@
           <a:p>
             <a:fld id="{8727B1B5-114F-462F-9F43-A96471EB3E77}" type="datetimeFigureOut">
               <a:rPr lang="en-GB" smtClean="0"/>
-              <a:t>29/05/2026</a:t>
+              <a:t>31/05/2026</a:t>
             </a:fld>
             <a:endParaRPr lang="en-GB"/>
           </a:p>
@@ -1425,7 +1865,7 @@
           <a:p>
             <a:fld id="{8727B1B5-114F-462F-9F43-A96471EB3E77}" type="datetimeFigureOut">
               <a:rPr lang="en-GB" smtClean="0"/>
-              <a:t>29/05/2026</a:t>
+              <a:t>31/05/2026</a:t>
             </a:fld>
             <a:endParaRPr lang="en-GB"/>
           </a:p>
@@ -1840,7 +2280,7 @@
           <a:p>
             <a:fld id="{8727B1B5-114F-462F-9F43-A96471EB3E77}" type="datetimeFigureOut">
               <a:rPr lang="en-GB" smtClean="0"/>
-              <a:t>29/05/2026</a:t>
+              <a:t>31/05/2026</a:t>
             </a:fld>
             <a:endParaRPr lang="en-GB"/>
           </a:p>
@@ -1982,7 +2422,7 @@
           <a:p>
             <a:fld id="{8727B1B5-114F-462F-9F43-A96471EB3E77}" type="datetimeFigureOut">
               <a:rPr lang="en-GB" smtClean="0"/>
-              <a:t>29/05/2026</a:t>
+              <a:t>31/05/2026</a:t>
             </a:fld>
             <a:endParaRPr lang="en-GB"/>
           </a:p>
@@ -2095,7 +2535,7 @@
           <a:p>
             <a:fld id="{8727B1B5-114F-462F-9F43-A96471EB3E77}" type="datetimeFigureOut">
               <a:rPr lang="en-GB" smtClean="0"/>
-              <a:t>29/05/2026</a:t>
+              <a:t>31/05/2026</a:t>
             </a:fld>
             <a:endParaRPr lang="en-GB"/>
           </a:p>
@@ -2408,7 +2848,7 @@
           <a:p>
             <a:fld id="{8727B1B5-114F-462F-9F43-A96471EB3E77}" type="datetimeFigureOut">
               <a:rPr lang="en-GB" smtClean="0"/>
-              <a:t>29/05/2026</a:t>
+              <a:t>31/05/2026</a:t>
             </a:fld>
             <a:endParaRPr lang="en-GB"/>
           </a:p>
@@ -2697,7 +3137,7 @@
           <a:p>
             <a:fld id="{8727B1B5-114F-462F-9F43-A96471EB3E77}" type="datetimeFigureOut">
               <a:rPr lang="en-GB" smtClean="0"/>
-              <a:t>29/05/2026</a:t>
+              <a:t>31/05/2026</a:t>
             </a:fld>
             <a:endParaRPr lang="en-GB"/>
           </a:p>
@@ -2940,7 +3380,7 @@
           <a:p>
             <a:fld id="{8727B1B5-114F-462F-9F43-A96471EB3E77}" type="datetimeFigureOut">
               <a:rPr lang="en-GB" smtClean="0"/>
-              <a:t>29/05/2026</a:t>
+              <a:t>31/05/2026</a:t>
             </a:fld>
             <a:endParaRPr lang="en-GB"/>
           </a:p>
@@ -3537,6 +3977,565 @@
           <p:cNvPr id="3" name="TextBox 2">
             <a:extLst>
               <a:ext uri="{FF2B5EF4-FFF2-40B4-BE49-F238E27FC236}">
+                <a16:creationId xmlns:a16="http://schemas.microsoft.com/office/drawing/2014/main" id="{9E4477BC-B009-9F2D-792B-5ABADDF67C8C}"/>
+              </a:ext>
+            </a:extLst>
+          </p:cNvPr>
+          <p:cNvSpPr txBox="1"/>
+          <p:nvPr/>
+        </p:nvSpPr>
+        <p:spPr>
+          <a:xfrm>
+            <a:off x="7639665" y="2396131"/>
+            <a:ext cx="6096000" cy="2400657"/>
+          </a:xfrm>
+          <a:prstGeom prst="rect">
+            <a:avLst/>
+          </a:prstGeom>
+          <a:noFill/>
+        </p:spPr>
+        <p:txBody>
+          <a:bodyPr wrap="square">
+            <a:spAutoFit/>
+          </a:bodyPr>
+          <a:lstStyle/>
+          <a:p>
+            <a:r>
+              <a:rPr lang="en-GB" sz="3200" b="1" dirty="0"/>
+              <a:t>Exploratory Data Analysis</a:t>
+            </a:r>
+          </a:p>
+          <a:p>
+            <a:endParaRPr lang="en-GB" dirty="0"/>
+          </a:p>
+          <a:p>
+            <a:r>
+              <a:rPr lang="en-GB" sz="2000" dirty="0"/>
+              <a:t>• Disease distribution analysis.</a:t>
+            </a:r>
+          </a:p>
+          <a:p>
+            <a:r>
+              <a:rPr lang="en-GB" sz="2000" dirty="0"/>
+              <a:t>• Gender and city-wise analysis.</a:t>
+            </a:r>
+          </a:p>
+          <a:p>
+            <a:r>
+              <a:rPr lang="en-GB" sz="2000" dirty="0"/>
+              <a:t>• Admission status analysis.</a:t>
+            </a:r>
+          </a:p>
+          <a:p>
+            <a:r>
+              <a:rPr lang="en-GB" sz="2000" dirty="0"/>
+              <a:t>• Treatment cost statistics.</a:t>
+            </a:r>
+          </a:p>
+          <a:p>
+            <a:r>
+              <a:rPr lang="en-GB" sz="2000" dirty="0"/>
+              <a:t>• Generated healthcare insights.</a:t>
+            </a:r>
+          </a:p>
+        </p:txBody>
+      </p:sp>
+      <p:pic>
+        <p:nvPicPr>
+          <p:cNvPr id="5" name="Picture 4">
+            <a:extLst>
+              <a:ext uri="{FF2B5EF4-FFF2-40B4-BE49-F238E27FC236}">
+                <a16:creationId xmlns:a16="http://schemas.microsoft.com/office/drawing/2014/main" id="{AB95E666-E490-C7ED-937D-DC532D93691F}"/>
+              </a:ext>
+            </a:extLst>
+          </p:cNvPr>
+          <p:cNvPicPr>
+            <a:picLocks noChangeAspect="1"/>
+          </p:cNvPicPr>
+          <p:nvPr/>
+        </p:nvPicPr>
+        <p:blipFill>
+          <a:blip r:embed="rId2">
+            <a:extLst>
+              <a:ext uri="{28A0092B-C50C-407E-A947-70E740481C1C}">
+                <a14:useLocalDpi xmlns:a14="http://schemas.microsoft.com/office/drawing/2010/main" val="0"/>
+              </a:ext>
+            </a:extLst>
+          </a:blip>
+          <a:stretch>
+            <a:fillRect/>
+          </a:stretch>
+        </p:blipFill>
+        <p:spPr>
+          <a:xfrm>
+            <a:off x="168130" y="247650"/>
+            <a:ext cx="7373211" cy="6362700"/>
+          </a:xfrm>
+          <a:prstGeom prst="rect">
+            <a:avLst/>
+          </a:prstGeom>
+          <a:solidFill>
+            <a:srgbClr val="FFFFFF">
+              <a:shade val="85000"/>
+            </a:srgbClr>
+          </a:solidFill>
+          <a:ln w="88900" cap="sq">
+            <a:solidFill>
+              <a:srgbClr val="FFFFFF"/>
+            </a:solidFill>
+            <a:miter lim="800000"/>
+          </a:ln>
+          <a:effectLst>
+            <a:outerShdw blurRad="55000" dist="18000" dir="5400000" algn="tl" rotWithShape="0">
+              <a:srgbClr val="000000">
+                <a:alpha val="40000"/>
+              </a:srgbClr>
+            </a:outerShdw>
+          </a:effectLst>
+          <a:scene3d>
+            <a:camera prst="orthographicFront"/>
+            <a:lightRig rig="twoPt" dir="t">
+              <a:rot lat="0" lon="0" rev="7200000"/>
+            </a:lightRig>
+          </a:scene3d>
+          <a:sp3d>
+            <a:bevelT w="25400" h="19050"/>
+            <a:contourClr>
+              <a:srgbClr val="FFFFFF"/>
+            </a:contourClr>
+          </a:sp3d>
+        </p:spPr>
+      </p:pic>
+    </p:spTree>
+    <p:extLst>
+      <p:ext uri="{BB962C8B-B14F-4D97-AF65-F5344CB8AC3E}">
+        <p14:creationId xmlns:p14="http://schemas.microsoft.com/office/powerpoint/2010/main" val="1555976044"/>
+      </p:ext>
+    </p:extLst>
+  </p:cSld>
+  <p:clrMapOvr>
+    <a:masterClrMapping/>
+  </p:clrMapOvr>
+</p:sld>
+</file>
+
+<file path=ppt/slides/slide11.xml><?xml version="1.0" encoding="utf-8"?>
+<p:sld xmlns:a="http://schemas.openxmlformats.org/drawingml/2006/main" xmlns:r="http://schemas.openxmlformats.org/officeDocument/2006/relationships" xmlns:p="http://schemas.openxmlformats.org/presentationml/2006/main">
+  <p:cSld>
+    <p:spTree>
+      <p:nvGrpSpPr>
+        <p:cNvPr id="1" name=""/>
+        <p:cNvGrpSpPr/>
+        <p:nvPr/>
+      </p:nvGrpSpPr>
+      <p:grpSpPr>
+        <a:xfrm>
+          <a:off x="0" y="0"/>
+          <a:ext cx="0" cy="0"/>
+          <a:chOff x="0" y="0"/>
+          <a:chExt cx="0" cy="0"/>
+        </a:xfrm>
+      </p:grpSpPr>
+      <p:sp>
+        <p:nvSpPr>
+          <p:cNvPr id="3" name="TextBox 2">
+            <a:extLst>
+              <a:ext uri="{FF2B5EF4-FFF2-40B4-BE49-F238E27FC236}">
+                <a16:creationId xmlns:a16="http://schemas.microsoft.com/office/drawing/2014/main" id="{4BB448C2-9C61-238F-4940-6D285C14ED9C}"/>
+              </a:ext>
+            </a:extLst>
+          </p:cNvPr>
+          <p:cNvSpPr txBox="1"/>
+          <p:nvPr/>
+        </p:nvSpPr>
+        <p:spPr>
+          <a:xfrm>
+            <a:off x="680022" y="5051687"/>
+            <a:ext cx="4324596" cy="1354217"/>
+          </a:xfrm>
+          <a:prstGeom prst="rect">
+            <a:avLst/>
+          </a:prstGeom>
+          <a:noFill/>
+        </p:spPr>
+        <p:txBody>
+          <a:bodyPr wrap="square">
+            <a:spAutoFit/>
+          </a:bodyPr>
+          <a:lstStyle/>
+          <a:p>
+            <a:r>
+              <a:rPr lang="en-GB" sz="3200" b="1" dirty="0"/>
+              <a:t>Machine Learning Model</a:t>
+            </a:r>
+          </a:p>
+          <a:p>
+            <a:endParaRPr lang="en-GB" dirty="0"/>
+          </a:p>
+        </p:txBody>
+      </p:sp>
+      <p:pic>
+        <p:nvPicPr>
+          <p:cNvPr id="5" name="Picture 4">
+            <a:extLst>
+              <a:ext uri="{FF2B5EF4-FFF2-40B4-BE49-F238E27FC236}">
+                <a16:creationId xmlns:a16="http://schemas.microsoft.com/office/drawing/2014/main" id="{A5D5C314-CBCF-CD42-FD1D-5ED2C119DB95}"/>
+              </a:ext>
+            </a:extLst>
+          </p:cNvPr>
+          <p:cNvPicPr>
+            <a:picLocks noChangeAspect="1"/>
+          </p:cNvPicPr>
+          <p:nvPr/>
+        </p:nvPicPr>
+        <p:blipFill>
+          <a:blip r:embed="rId3">
+            <a:extLst>
+              <a:ext uri="{28A0092B-C50C-407E-A947-70E740481C1C}">
+                <a14:useLocalDpi xmlns:a14="http://schemas.microsoft.com/office/drawing/2010/main" val="0"/>
+              </a:ext>
+            </a:extLst>
+          </a:blip>
+          <a:stretch>
+            <a:fillRect/>
+          </a:stretch>
+        </p:blipFill>
+        <p:spPr>
+          <a:xfrm>
+            <a:off x="286733" y="286034"/>
+            <a:ext cx="11472648" cy="3723433"/>
+          </a:xfrm>
+          <a:prstGeom prst="rect">
+            <a:avLst/>
+          </a:prstGeom>
+          <a:solidFill>
+            <a:srgbClr val="FFFFFF">
+              <a:shade val="85000"/>
+            </a:srgbClr>
+          </a:solidFill>
+          <a:ln w="88900" cap="sq">
+            <a:solidFill>
+              <a:srgbClr val="FFFFFF"/>
+            </a:solidFill>
+            <a:miter lim="800000"/>
+          </a:ln>
+          <a:effectLst>
+            <a:outerShdw blurRad="55000" dist="18000" dir="5400000" algn="tl" rotWithShape="0">
+              <a:srgbClr val="000000">
+                <a:alpha val="40000"/>
+              </a:srgbClr>
+            </a:outerShdw>
+          </a:effectLst>
+          <a:scene3d>
+            <a:camera prst="orthographicFront"/>
+            <a:lightRig rig="twoPt" dir="t">
+              <a:rot lat="0" lon="0" rev="7200000"/>
+            </a:lightRig>
+          </a:scene3d>
+          <a:sp3d>
+            <a:bevelT w="25400" h="19050"/>
+            <a:contourClr>
+              <a:srgbClr val="FFFFFF"/>
+            </a:contourClr>
+          </a:sp3d>
+        </p:spPr>
+      </p:pic>
+      <p:sp>
+        <p:nvSpPr>
+          <p:cNvPr id="4" name="TextBox 3">
+            <a:extLst>
+              <a:ext uri="{FF2B5EF4-FFF2-40B4-BE49-F238E27FC236}">
+                <a16:creationId xmlns:a16="http://schemas.microsoft.com/office/drawing/2014/main" id="{3A475FCB-EE74-3C6C-AC91-FDF15EC93828}"/>
+              </a:ext>
+            </a:extLst>
+          </p:cNvPr>
+          <p:cNvSpPr txBox="1"/>
+          <p:nvPr/>
+        </p:nvSpPr>
+        <p:spPr>
+          <a:xfrm>
+            <a:off x="6023057" y="4725490"/>
+            <a:ext cx="6096000" cy="1323439"/>
+          </a:xfrm>
+          <a:prstGeom prst="rect">
+            <a:avLst/>
+          </a:prstGeom>
+          <a:noFill/>
+        </p:spPr>
+        <p:txBody>
+          <a:bodyPr wrap="square">
+            <a:spAutoFit/>
+          </a:bodyPr>
+          <a:lstStyle/>
+          <a:p>
+            <a:r>
+              <a:rPr lang="en-GB" sz="2000" dirty="0"/>
+              <a:t>• Random Forest Regressor implemented.</a:t>
+            </a:r>
+          </a:p>
+          <a:p>
+            <a:r>
+              <a:rPr lang="en-GB" sz="2000" dirty="0"/>
+              <a:t>• Treatment cost prediction performed.</a:t>
+            </a:r>
+          </a:p>
+          <a:p>
+            <a:r>
+              <a:rPr lang="en-GB" sz="2000" dirty="0"/>
+              <a:t>• Model trained on healthcare dataset.</a:t>
+            </a:r>
+          </a:p>
+          <a:p>
+            <a:r>
+              <a:rPr lang="en-GB" sz="2000" dirty="0"/>
+              <a:t>• Performance evaluated using MAE.</a:t>
+            </a:r>
+          </a:p>
+        </p:txBody>
+      </p:sp>
+    </p:spTree>
+    <p:extLst>
+      <p:ext uri="{BB962C8B-B14F-4D97-AF65-F5344CB8AC3E}">
+        <p14:creationId xmlns:p14="http://schemas.microsoft.com/office/powerpoint/2010/main" val="2032054767"/>
+      </p:ext>
+    </p:extLst>
+  </p:cSld>
+  <p:clrMapOvr>
+    <a:masterClrMapping/>
+  </p:clrMapOvr>
+</p:sld>
+</file>
+
+<file path=ppt/slides/slide12.xml><?xml version="1.0" encoding="utf-8"?>
+<p:sld xmlns:a="http://schemas.openxmlformats.org/drawingml/2006/main" xmlns:r="http://schemas.openxmlformats.org/officeDocument/2006/relationships" xmlns:p="http://schemas.openxmlformats.org/presentationml/2006/main">
+  <p:cSld>
+    <p:spTree>
+      <p:nvGrpSpPr>
+        <p:cNvPr id="1" name=""/>
+        <p:cNvGrpSpPr/>
+        <p:nvPr/>
+      </p:nvGrpSpPr>
+      <p:grpSpPr>
+        <a:xfrm>
+          <a:off x="0" y="0"/>
+          <a:ext cx="0" cy="0"/>
+          <a:chOff x="0" y="0"/>
+          <a:chExt cx="0" cy="0"/>
+        </a:xfrm>
+      </p:grpSpPr>
+      <p:sp>
+        <p:nvSpPr>
+          <p:cNvPr id="3" name="TextBox 2">
+            <a:extLst>
+              <a:ext uri="{FF2B5EF4-FFF2-40B4-BE49-F238E27FC236}">
+                <a16:creationId xmlns:a16="http://schemas.microsoft.com/office/drawing/2014/main" id="{703B2267-BFCE-66E7-D000-E9D18EEFD2A0}"/>
+              </a:ext>
+            </a:extLst>
+          </p:cNvPr>
+          <p:cNvSpPr txBox="1"/>
+          <p:nvPr/>
+        </p:nvSpPr>
+        <p:spPr>
+          <a:xfrm>
+            <a:off x="779206" y="4844210"/>
+            <a:ext cx="6096000" cy="1077218"/>
+          </a:xfrm>
+          <a:prstGeom prst="rect">
+            <a:avLst/>
+          </a:prstGeom>
+          <a:noFill/>
+        </p:spPr>
+        <p:txBody>
+          <a:bodyPr wrap="square">
+            <a:spAutoFit/>
+          </a:bodyPr>
+          <a:lstStyle/>
+          <a:p>
+            <a:r>
+              <a:rPr lang="en-GB" sz="3200" b="1" dirty="0"/>
+              <a:t>CI/CD Automation using</a:t>
+            </a:r>
+          </a:p>
+          <a:p>
+            <a:r>
+              <a:rPr lang="en-GB" sz="3200" b="1" dirty="0"/>
+              <a:t>GitHub Actions</a:t>
+            </a:r>
+          </a:p>
+        </p:txBody>
+      </p:sp>
+      <p:sp>
+        <p:nvSpPr>
+          <p:cNvPr id="5" name="TextBox 4">
+            <a:extLst>
+              <a:ext uri="{FF2B5EF4-FFF2-40B4-BE49-F238E27FC236}">
+                <a16:creationId xmlns:a16="http://schemas.microsoft.com/office/drawing/2014/main" id="{94D172F4-AB06-A8D1-F0F8-223E1C869729}"/>
+              </a:ext>
+            </a:extLst>
+          </p:cNvPr>
+          <p:cNvSpPr txBox="1"/>
+          <p:nvPr/>
+        </p:nvSpPr>
+        <p:spPr>
+          <a:xfrm>
+            <a:off x="5665837" y="4377422"/>
+            <a:ext cx="6456108" cy="2246769"/>
+          </a:xfrm>
+          <a:prstGeom prst="rect">
+            <a:avLst/>
+          </a:prstGeom>
+          <a:noFill/>
+        </p:spPr>
+        <p:txBody>
+          <a:bodyPr wrap="square">
+            <a:spAutoFit/>
+          </a:bodyPr>
+          <a:lstStyle/>
+          <a:p>
+            <a:r>
+              <a:rPr lang="en-GB" sz="2000" dirty="0"/>
+              <a:t>• GitHub Actions workflow implemented</a:t>
+            </a:r>
+          </a:p>
+          <a:p>
+            <a:r>
+              <a:rPr lang="en-GB" sz="2000" dirty="0"/>
+              <a:t>• Automated code validation and execution</a:t>
+            </a:r>
+          </a:p>
+          <a:p>
+            <a:r>
+              <a:rPr lang="en-GB" sz="2000" dirty="0"/>
+              <a:t>• Continuous Integration (CI) pipeline</a:t>
+            </a:r>
+          </a:p>
+          <a:p>
+            <a:r>
+              <a:rPr lang="en-GB" sz="2000" dirty="0"/>
+              <a:t>• Automatic workflow execution on </a:t>
+            </a:r>
+          </a:p>
+          <a:p>
+            <a:r>
+              <a:rPr lang="en-GB" sz="2000" dirty="0"/>
+              <a:t>   code updates</a:t>
+            </a:r>
+          </a:p>
+          <a:p>
+            <a:r>
+              <a:rPr lang="en-GB" sz="2000" dirty="0"/>
+              <a:t>• Improved deployment and maintenance </a:t>
+            </a:r>
+          </a:p>
+          <a:p>
+            <a:r>
+              <a:rPr lang="en-GB" sz="2000" dirty="0"/>
+              <a:t>   readiness</a:t>
+            </a:r>
+          </a:p>
+        </p:txBody>
+      </p:sp>
+      <p:pic>
+        <p:nvPicPr>
+          <p:cNvPr id="7" name="Picture 6">
+            <a:extLst>
+              <a:ext uri="{FF2B5EF4-FFF2-40B4-BE49-F238E27FC236}">
+                <a16:creationId xmlns:a16="http://schemas.microsoft.com/office/drawing/2014/main" id="{37ACE042-9936-B330-8F17-E45C9F244C13}"/>
+              </a:ext>
+            </a:extLst>
+          </p:cNvPr>
+          <p:cNvPicPr>
+            <a:picLocks noChangeAspect="1"/>
+          </p:cNvPicPr>
+          <p:nvPr/>
+        </p:nvPicPr>
+        <p:blipFill>
+          <a:blip r:embed="rId2">
+            <a:extLst>
+              <a:ext uri="{28A0092B-C50C-407E-A947-70E740481C1C}">
+                <a14:useLocalDpi xmlns:a14="http://schemas.microsoft.com/office/drawing/2010/main" val="0"/>
+              </a:ext>
+            </a:extLst>
+          </a:blip>
+          <a:stretch>
+            <a:fillRect/>
+          </a:stretch>
+        </p:blipFill>
+        <p:spPr>
+          <a:xfrm>
+            <a:off x="70054" y="139602"/>
+            <a:ext cx="12051891" cy="4082672"/>
+          </a:xfrm>
+          <a:prstGeom prst="rect">
+            <a:avLst/>
+          </a:prstGeom>
+          <a:solidFill>
+            <a:srgbClr val="FFFFFF">
+              <a:shade val="85000"/>
+            </a:srgbClr>
+          </a:solidFill>
+          <a:ln w="88900" cap="sq">
+            <a:solidFill>
+              <a:srgbClr val="FFFFFF"/>
+            </a:solidFill>
+            <a:miter lim="800000"/>
+          </a:ln>
+          <a:effectLst>
+            <a:outerShdw blurRad="55000" dist="18000" dir="5400000" algn="tl" rotWithShape="0">
+              <a:srgbClr val="000000">
+                <a:alpha val="40000"/>
+              </a:srgbClr>
+            </a:outerShdw>
+          </a:effectLst>
+          <a:scene3d>
+            <a:camera prst="orthographicFront"/>
+            <a:lightRig rig="twoPt" dir="t">
+              <a:rot lat="0" lon="0" rev="7200000"/>
+            </a:lightRig>
+          </a:scene3d>
+          <a:sp3d>
+            <a:bevelT w="25400" h="19050"/>
+            <a:contourClr>
+              <a:srgbClr val="FFFFFF"/>
+            </a:contourClr>
+          </a:sp3d>
+        </p:spPr>
+      </p:pic>
+    </p:spTree>
+    <p:extLst>
+      <p:ext uri="{BB962C8B-B14F-4D97-AF65-F5344CB8AC3E}">
+        <p14:creationId xmlns:p14="http://schemas.microsoft.com/office/powerpoint/2010/main" val="1395221662"/>
+      </p:ext>
+    </p:extLst>
+  </p:cSld>
+  <p:clrMapOvr>
+    <a:masterClrMapping/>
+  </p:clrMapOvr>
+</p:sld>
+</file>
+
+<file path=ppt/slides/slide13.xml><?xml version="1.0" encoding="utf-8"?>
+<p:sld xmlns:a="http://schemas.openxmlformats.org/drawingml/2006/main" xmlns:r="http://schemas.openxmlformats.org/officeDocument/2006/relationships" xmlns:p="http://schemas.openxmlformats.org/presentationml/2006/main">
+  <p:cSld>
+    <p:spTree>
+      <p:nvGrpSpPr>
+        <p:cNvPr id="1" name=""/>
+        <p:cNvGrpSpPr/>
+        <p:nvPr/>
+      </p:nvGrpSpPr>
+      <p:grpSpPr>
+        <a:xfrm>
+          <a:off x="0" y="0"/>
+          <a:ext cx="0" cy="0"/>
+          <a:chOff x="0" y="0"/>
+          <a:chExt cx="0" cy="0"/>
+        </a:xfrm>
+      </p:grpSpPr>
+      <p:sp>
+        <p:nvSpPr>
+          <p:cNvPr id="3" name="TextBox 2">
+            <a:extLst>
+              <a:ext uri="{FF2B5EF4-FFF2-40B4-BE49-F238E27FC236}">
                 <a16:creationId xmlns:a16="http://schemas.microsoft.com/office/drawing/2014/main" id="{BC28EFC9-B009-31E0-2BFA-83B6ADC518C1}"/>
               </a:ext>
             </a:extLst>
@@ -3561,7 +4560,7 @@
           <a:lstStyle/>
           <a:p>
             <a:r>
-              <a:rPr lang="en-US" sz="3200" dirty="0"/>
+              <a:rPr lang="en-US" sz="3200" b="1" dirty="0"/>
               <a:t>Interactive Dashboard</a:t>
             </a:r>
           </a:p>
@@ -3733,7 +4732,7 @@
 </p:sld>
 </file>
 
-<file path=ppt/slides/slide11.xml><?xml version="1.0" encoding="utf-8"?>
+<file path=ppt/slides/slide14.xml><?xml version="1.0" encoding="utf-8"?>
 <p:sld xmlns:a="http://schemas.openxmlformats.org/drawingml/2006/main" xmlns:r="http://schemas.openxmlformats.org/officeDocument/2006/relationships" xmlns:p="http://schemas.openxmlformats.org/presentationml/2006/main">
   <p:cSld>
     <p:spTree>
@@ -3764,8 +4763,8 @@
         </p:nvSpPr>
         <p:spPr>
           <a:xfrm>
-            <a:off x="1061884" y="874334"/>
-            <a:ext cx="6096000" cy="5324535"/>
+            <a:off x="1081549" y="458956"/>
+            <a:ext cx="6096000" cy="6093976"/>
           </a:xfrm>
           <a:prstGeom prst="rect">
             <a:avLst/>
@@ -3779,7 +4778,7 @@
           <a:lstStyle/>
           <a:p>
             <a:r>
-              <a:rPr lang="en-GB" sz="3200" dirty="0"/>
+              <a:rPr lang="en-GB" sz="3200" b="1" dirty="0"/>
               <a:t>Conclusion &amp; Future Scope</a:t>
             </a:r>
           </a:p>
@@ -3795,8 +4794,19 @@
           <a:p>
             <a:r>
               <a:rPr lang="en-GB" sz="2000" dirty="0"/>
-              <a:t>• Integrated AWS S3, Airflow, PySpark and PostgreSQL.</a:t>
-            </a:r>
+              <a:t>• </a:t>
+            </a:r>
+            <a:r>
+              <a:rPr lang="en-US" sz="2000" dirty="0"/>
+              <a:t>Integrated AWS S3, Apache Kafka, Databricks, </a:t>
+            </a:r>
+          </a:p>
+          <a:p>
+            <a:r>
+              <a:rPr lang="en-US" sz="2000" dirty="0"/>
+              <a:t>   Airflow, PySpark and PostgreSQL.</a:t>
+            </a:r>
+            <a:endParaRPr lang="en-GB" sz="2000" dirty="0"/>
           </a:p>
           <a:p>
             <a:r>
@@ -3817,11 +4827,18 @@
             </a:r>
           </a:p>
           <a:p>
+            <a:r>
+              <a:rPr lang="en-US" sz="2000" dirty="0"/>
+              <a:t>• Implemented GitHub Actions based CI/CD workflow.</a:t>
+            </a:r>
+            <a:endParaRPr lang="en-GB" sz="2000" dirty="0"/>
+          </a:p>
+          <a:p>
             <a:endParaRPr lang="en-GB" dirty="0"/>
           </a:p>
           <a:p>
             <a:r>
-              <a:rPr lang="en-GB" sz="3200" dirty="0"/>
+              <a:rPr lang="en-GB" sz="3200" b="1" dirty="0"/>
               <a:t>Future Scope</a:t>
             </a:r>
           </a:p>
@@ -3830,34 +4847,34 @@
           </a:p>
           <a:p>
             <a:r>
-              <a:rPr lang="en-GB" sz="2000" dirty="0"/>
-              <a:t>• Real-time healthcare data processing.</a:t>
-            </a:r>
-          </a:p>
-          <a:p>
-            <a:r>
-              <a:rPr lang="en-GB" sz="2000" dirty="0"/>
-              <a:t>• Advanced predictive analytics.</a:t>
-            </a:r>
-          </a:p>
-          <a:p>
-            <a:r>
-              <a:rPr lang="en-GB" sz="2000" dirty="0"/>
-              <a:t>• Integration with hospital information systems.</a:t>
-            </a:r>
-          </a:p>
-          <a:p>
-            <a:r>
-              <a:rPr lang="en-GB" sz="2000" dirty="0"/>
-              <a:t>• Enterprise-scale cloud deployment.</a:t>
-            </a:r>
-          </a:p>
-          <a:p>
-            <a:endParaRPr lang="en-GB" dirty="0"/>
-          </a:p>
-          <a:p>
-            <a:r>
-              <a:rPr lang="en-GB" sz="2400" dirty="0"/>
+              <a:rPr lang="en-US" sz="2000" dirty="0"/>
+              <a:t>• Snowflake Data Warehouse integration</a:t>
+            </a:r>
+          </a:p>
+          <a:p>
+            <a:r>
+              <a:rPr lang="en-US" sz="2000" dirty="0"/>
+              <a:t>• Kubernetes-based container orchestration</a:t>
+            </a:r>
+          </a:p>
+          <a:p>
+            <a:r>
+              <a:rPr lang="en-US" sz="2000" dirty="0"/>
+              <a:t>• Advanced predictive analytics</a:t>
+            </a:r>
+          </a:p>
+          <a:p>
+            <a:r>
+              <a:rPr lang="en-US" sz="2000" dirty="0"/>
+              <a:t>• Integration with hospital information systems</a:t>
+            </a:r>
+          </a:p>
+          <a:p>
+            <a:endParaRPr lang="en-GB" sz="2000" dirty="0"/>
+          </a:p>
+          <a:p>
+            <a:r>
+              <a:rPr lang="en-GB" sz="3200" b="1" dirty="0"/>
               <a:t>Thank You</a:t>
             </a:r>
           </a:p>
@@ -3922,7 +4939,7 @@
           <a:lstStyle/>
           <a:p>
             <a:r>
-              <a:rPr lang="en-GB" sz="3200" dirty="0"/>
+              <a:rPr lang="en-GB" sz="3200" b="1" dirty="0"/>
               <a:t>Problem Statement</a:t>
             </a:r>
           </a:p>
@@ -3964,7 +4981,7 @@
           </a:p>
           <a:p>
             <a:r>
-              <a:rPr lang="en-GB" sz="3200" dirty="0"/>
+              <a:rPr lang="en-GB" sz="3200" b="1" dirty="0"/>
               <a:t>Objective</a:t>
             </a:r>
           </a:p>
@@ -4030,12 +5047,99 @@
           <a:chExt cx="0" cy="0"/>
         </a:xfrm>
       </p:grpSpPr>
+      <p:sp>
+        <p:nvSpPr>
+          <p:cNvPr id="12" name="TextBox 11">
+            <a:extLst>
+              <a:ext uri="{FF2B5EF4-FFF2-40B4-BE49-F238E27FC236}">
+                <a16:creationId xmlns:a16="http://schemas.microsoft.com/office/drawing/2014/main" id="{EB4572C8-AA43-1CD6-AEA6-E125AFD33848}"/>
+              </a:ext>
+            </a:extLst>
+          </p:cNvPr>
+          <p:cNvSpPr txBox="1"/>
+          <p:nvPr/>
+        </p:nvSpPr>
+        <p:spPr>
+          <a:xfrm>
+            <a:off x="6027174" y="1197620"/>
+            <a:ext cx="6096000" cy="3539430"/>
+          </a:xfrm>
+          <a:prstGeom prst="rect">
+            <a:avLst/>
+          </a:prstGeom>
+          <a:noFill/>
+        </p:spPr>
+        <p:txBody>
+          <a:bodyPr wrap="square">
+            <a:spAutoFit/>
+          </a:bodyPr>
+          <a:lstStyle/>
+          <a:p>
+            <a:r>
+              <a:rPr lang="en-US" sz="3200" b="1" dirty="0"/>
+              <a:t>Project Architecture</a:t>
+            </a:r>
+          </a:p>
+          <a:p>
+            <a:endParaRPr lang="en-US" sz="3200" b="1" dirty="0"/>
+          </a:p>
+          <a:p>
+            <a:r>
+              <a:rPr lang="en-US" sz="2000" dirty="0"/>
+              <a:t>• Cloud-based end-to-end analytics pipeline</a:t>
+            </a:r>
+          </a:p>
+          <a:p>
+            <a:r>
+              <a:rPr lang="en-US" sz="2000" dirty="0"/>
+              <a:t>• Real-time streaming capability using Apache Kafka</a:t>
+            </a:r>
+          </a:p>
+          <a:p>
+            <a:r>
+              <a:rPr lang="en-US" sz="2000" dirty="0"/>
+              <a:t>• Databricks-powered PySpark processing</a:t>
+            </a:r>
+          </a:p>
+          <a:p>
+            <a:r>
+              <a:rPr lang="en-US" sz="2000" dirty="0"/>
+              <a:t>• Automated workflow orchestration using Airflow</a:t>
+            </a:r>
+          </a:p>
+          <a:p>
+            <a:r>
+              <a:rPr lang="en-US" sz="2000" dirty="0"/>
+              <a:t>• Star Schema Data Warehouse for analytics</a:t>
+            </a:r>
+          </a:p>
+          <a:p>
+            <a:r>
+              <a:rPr lang="en-US" sz="2000" dirty="0"/>
+              <a:t>• Machine Learning based predictive analytics</a:t>
+            </a:r>
+          </a:p>
+          <a:p>
+            <a:r>
+              <a:rPr lang="en-US" sz="2000" dirty="0"/>
+              <a:t>• CI/CD automation using GitHub Actions</a:t>
+            </a:r>
+          </a:p>
+          <a:p>
+            <a:r>
+              <a:rPr lang="en-US" sz="2000" dirty="0"/>
+              <a:t>• Interactive Streamlit dashboard for reporting</a:t>
+            </a:r>
+            <a:endParaRPr lang="en-GB" sz="2000" dirty="0"/>
+          </a:p>
+        </p:txBody>
+      </p:sp>
       <p:pic>
         <p:nvPicPr>
-          <p:cNvPr id="10" name="Picture 9">
-            <a:extLst>
-              <a:ext uri="{FF2B5EF4-FFF2-40B4-BE49-F238E27FC236}">
-                <a16:creationId xmlns:a16="http://schemas.microsoft.com/office/drawing/2014/main" id="{99FEFEA3-7CD9-A3A5-E92C-859F53A54A81}"/>
+          <p:cNvPr id="4" name="Picture 3">
+            <a:extLst>
+              <a:ext uri="{FF2B5EF4-FFF2-40B4-BE49-F238E27FC236}">
+                <a16:creationId xmlns:a16="http://schemas.microsoft.com/office/drawing/2014/main" id="{147C65BD-CB16-3B70-AAB3-3E8AD15ABBDE}"/>
               </a:ext>
             </a:extLst>
           </p:cNvPr>
@@ -4058,76 +5162,44 @@
         </p:blipFill>
         <p:spPr>
           <a:xfrm>
-            <a:off x="1008678" y="103238"/>
-            <a:ext cx="4572000" cy="6651523"/>
+            <a:off x="380999" y="167148"/>
+            <a:ext cx="5538020" cy="6449962"/>
           </a:xfrm>
           <a:prstGeom prst="rect">
             <a:avLst/>
           </a:prstGeom>
+          <a:solidFill>
+            <a:srgbClr val="FFFFFF">
+              <a:shade val="85000"/>
+            </a:srgbClr>
+          </a:solidFill>
+          <a:ln w="88900" cap="sq">
+            <a:solidFill>
+              <a:srgbClr val="FFFFFF"/>
+            </a:solidFill>
+            <a:miter lim="800000"/>
+          </a:ln>
+          <a:effectLst>
+            <a:outerShdw blurRad="55000" dist="18000" dir="5400000" algn="tl" rotWithShape="0">
+              <a:srgbClr val="000000">
+                <a:alpha val="40000"/>
+              </a:srgbClr>
+            </a:outerShdw>
+          </a:effectLst>
+          <a:scene3d>
+            <a:camera prst="orthographicFront"/>
+            <a:lightRig rig="twoPt" dir="t">
+              <a:rot lat="0" lon="0" rev="7200000"/>
+            </a:lightRig>
+          </a:scene3d>
+          <a:sp3d>
+            <a:bevelT w="25400" h="19050"/>
+            <a:contourClr>
+              <a:srgbClr val="FFFFFF"/>
+            </a:contourClr>
+          </a:sp3d>
         </p:spPr>
       </p:pic>
-      <p:sp>
-        <p:nvSpPr>
-          <p:cNvPr id="12" name="TextBox 11">
-            <a:extLst>
-              <a:ext uri="{FF2B5EF4-FFF2-40B4-BE49-F238E27FC236}">
-                <a16:creationId xmlns:a16="http://schemas.microsoft.com/office/drawing/2014/main" id="{EB4572C8-AA43-1CD6-AEA6-E125AFD33848}"/>
-              </a:ext>
-            </a:extLst>
-          </p:cNvPr>
-          <p:cNvSpPr txBox="1"/>
-          <p:nvPr/>
-        </p:nvSpPr>
-        <p:spPr>
-          <a:xfrm>
-            <a:off x="5732207" y="1964360"/>
-            <a:ext cx="6096000" cy="2092881"/>
-          </a:xfrm>
-          <a:prstGeom prst="rect">
-            <a:avLst/>
-          </a:prstGeom>
-          <a:noFill/>
-        </p:spPr>
-        <p:txBody>
-          <a:bodyPr wrap="square">
-            <a:spAutoFit/>
-          </a:bodyPr>
-          <a:lstStyle/>
-          <a:p>
-            <a:r>
-              <a:rPr lang="en-GB" sz="3200" b="1" dirty="0"/>
-              <a:t>Project Architecture</a:t>
-            </a:r>
-          </a:p>
-          <a:p>
-            <a:endParaRPr lang="en-GB" dirty="0"/>
-          </a:p>
-          <a:p>
-            <a:r>
-              <a:rPr lang="en-GB" sz="2000" dirty="0"/>
-              <a:t>• Cloud-based end-to-end analytics pipeline.</a:t>
-            </a:r>
-          </a:p>
-          <a:p>
-            <a:r>
-              <a:rPr lang="en-GB" sz="2000" dirty="0"/>
-              <a:t>• Automated data processing and workflow execution.</a:t>
-            </a:r>
-          </a:p>
-          <a:p>
-            <a:r>
-              <a:rPr lang="en-GB" sz="2000" dirty="0"/>
-              <a:t>• Data warehouse for analytical reporting.</a:t>
-            </a:r>
-          </a:p>
-          <a:p>
-            <a:r>
-              <a:rPr lang="en-GB" sz="2000" dirty="0"/>
-              <a:t>• Dashboard for healthcare insights.</a:t>
-            </a:r>
-          </a:p>
-        </p:txBody>
-      </p:sp>
     </p:spTree>
     <p:extLst>
       <p:ext uri="{BB962C8B-B14F-4D97-AF65-F5344CB8AC3E}">
@@ -4330,8 +5402,8 @@
         </p:nvSpPr>
         <p:spPr>
           <a:xfrm>
-            <a:off x="6902246" y="3498110"/>
-            <a:ext cx="6096000" cy="2400657"/>
+            <a:off x="6902246" y="3742526"/>
+            <a:ext cx="5034115" cy="2893100"/>
           </a:xfrm>
           <a:prstGeom prst="rect">
             <a:avLst/>
@@ -4345,8 +5417,8 @@
           <a:lstStyle/>
           <a:p>
             <a:r>
-              <a:rPr lang="en-GB" sz="3200" dirty="0"/>
-              <a:t>ETL Pipeline &amp; Airflow</a:t>
+              <a:rPr lang="en-GB" sz="3200" b="1" dirty="0"/>
+              <a:t>ETL Pipeline, Airflow &amp; Kafka</a:t>
             </a:r>
           </a:p>
           <a:p>
@@ -4416,8 +5488,8 @@
         </p:blipFill>
         <p:spPr>
           <a:xfrm>
-            <a:off x="586617" y="234622"/>
-            <a:ext cx="10268195" cy="2750820"/>
+            <a:off x="88490" y="148549"/>
+            <a:ext cx="11759382" cy="2750820"/>
           </a:xfrm>
           <a:prstGeom prst="rect">
             <a:avLst/>
@@ -4482,8 +5554,8 @@
         </p:blipFill>
         <p:spPr>
           <a:xfrm>
-            <a:off x="586618" y="3157589"/>
-            <a:ext cx="6315628" cy="3014611"/>
+            <a:off x="176981" y="3157589"/>
+            <a:ext cx="6725265" cy="3351366"/>
           </a:xfrm>
           <a:prstGeom prst="rect">
             <a:avLst/>
@@ -4550,12 +5622,144 @@
           <a:chExt cx="0" cy="0"/>
         </a:xfrm>
       </p:grpSpPr>
-      <p:sp>
-        <p:nvSpPr>
-          <p:cNvPr id="3" name="TextBox 2">
-            <a:extLst>
-              <a:ext uri="{FF2B5EF4-FFF2-40B4-BE49-F238E27FC236}">
-                <a16:creationId xmlns:a16="http://schemas.microsoft.com/office/drawing/2014/main" id="{28CC4748-A3E2-E458-ABFF-B841450C5EBD}"/>
+      <p:pic>
+        <p:nvPicPr>
+          <p:cNvPr id="7" name="Picture 6">
+            <a:extLst>
+              <a:ext uri="{FF2B5EF4-FFF2-40B4-BE49-F238E27FC236}">
+                <a16:creationId xmlns:a16="http://schemas.microsoft.com/office/drawing/2014/main" id="{A5DC1450-F404-7C1E-5C15-83BF7BCC33A7}"/>
+              </a:ext>
+            </a:extLst>
+          </p:cNvPr>
+          <p:cNvPicPr>
+            <a:picLocks noChangeAspect="1"/>
+          </p:cNvPicPr>
+          <p:nvPr/>
+        </p:nvPicPr>
+        <p:blipFill>
+          <a:blip r:embed="rId2">
+            <a:extLst>
+              <a:ext uri="{28A0092B-C50C-407E-A947-70E740481C1C}">
+                <a14:useLocalDpi xmlns:a14="http://schemas.microsoft.com/office/drawing/2010/main" val="0"/>
+              </a:ext>
+            </a:extLst>
+          </a:blip>
+          <a:stretch>
+            <a:fillRect/>
+          </a:stretch>
+        </p:blipFill>
+        <p:spPr>
+          <a:xfrm>
+            <a:off x="259080" y="3460649"/>
+            <a:ext cx="7406640" cy="1938798"/>
+          </a:xfrm>
+          <a:prstGeom prst="rect">
+            <a:avLst/>
+          </a:prstGeom>
+          <a:solidFill>
+            <a:srgbClr val="FFFFFF">
+              <a:shade val="85000"/>
+            </a:srgbClr>
+          </a:solidFill>
+          <a:ln w="88900" cap="sq">
+            <a:solidFill>
+              <a:srgbClr val="FFFFFF"/>
+            </a:solidFill>
+            <a:miter lim="800000"/>
+          </a:ln>
+          <a:effectLst>
+            <a:outerShdw blurRad="55000" dist="18000" dir="5400000" algn="tl" rotWithShape="0">
+              <a:srgbClr val="000000">
+                <a:alpha val="40000"/>
+              </a:srgbClr>
+            </a:outerShdw>
+          </a:effectLst>
+          <a:scene3d>
+            <a:camera prst="orthographicFront"/>
+            <a:lightRig rig="twoPt" dir="t">
+              <a:rot lat="0" lon="0" rev="7200000"/>
+            </a:lightRig>
+          </a:scene3d>
+          <a:sp3d>
+            <a:bevelT w="25400" h="19050"/>
+            <a:contourClr>
+              <a:srgbClr val="FFFFFF"/>
+            </a:contourClr>
+          </a:sp3d>
+        </p:spPr>
+      </p:pic>
+      <p:pic>
+        <p:nvPicPr>
+          <p:cNvPr id="9" name="Picture 8">
+            <a:extLst>
+              <a:ext uri="{FF2B5EF4-FFF2-40B4-BE49-F238E27FC236}">
+                <a16:creationId xmlns:a16="http://schemas.microsoft.com/office/drawing/2014/main" id="{3961F9EA-CE0D-AE09-7B4D-87AE19A97A55}"/>
+              </a:ext>
+            </a:extLst>
+          </p:cNvPr>
+          <p:cNvPicPr>
+            <a:picLocks noChangeAspect="1"/>
+          </p:cNvPicPr>
+          <p:nvPr/>
+        </p:nvPicPr>
+        <p:blipFill>
+          <a:blip r:embed="rId3">
+            <a:extLst>
+              <a:ext uri="{28A0092B-C50C-407E-A947-70E740481C1C}">
+                <a14:useLocalDpi xmlns:a14="http://schemas.microsoft.com/office/drawing/2010/main" val="0"/>
+              </a:ext>
+            </a:extLst>
+          </a:blip>
+          <a:stretch>
+            <a:fillRect/>
+          </a:stretch>
+        </p:blipFill>
+        <p:spPr>
+          <a:xfrm>
+            <a:off x="259080" y="1270818"/>
+            <a:ext cx="7406640" cy="1659195"/>
+          </a:xfrm>
+          <a:prstGeom prst="rect">
+            <a:avLst/>
+          </a:prstGeom>
+          <a:solidFill>
+            <a:srgbClr val="FFFFFF">
+              <a:shade val="85000"/>
+            </a:srgbClr>
+          </a:solidFill>
+          <a:ln w="88900" cap="sq">
+            <a:solidFill>
+              <a:srgbClr val="FFFFFF"/>
+            </a:solidFill>
+            <a:miter lim="800000"/>
+          </a:ln>
+          <a:effectLst>
+            <a:outerShdw blurRad="55000" dist="18000" dir="5400000" algn="tl" rotWithShape="0">
+              <a:srgbClr val="000000">
+                <a:alpha val="40000"/>
+              </a:srgbClr>
+            </a:outerShdw>
+          </a:effectLst>
+          <a:scene3d>
+            <a:camera prst="orthographicFront"/>
+            <a:lightRig rig="twoPt" dir="t">
+              <a:rot lat="0" lon="0" rev="7200000"/>
+            </a:lightRig>
+          </a:scene3d>
+          <a:sp3d>
+            <a:bevelT w="25400" h="19050"/>
+            <a:contourClr>
+              <a:srgbClr val="FFFFFF"/>
+            </a:contourClr>
+          </a:sp3d>
+        </p:spPr>
+      </p:pic>
+      <p:sp>
+        <p:nvSpPr>
+          <p:cNvPr id="11" name="TextBox 10">
+            <a:extLst>
+              <a:ext uri="{FF2B5EF4-FFF2-40B4-BE49-F238E27FC236}">
+                <a16:creationId xmlns:a16="http://schemas.microsoft.com/office/drawing/2014/main" id="{3FAEAC01-AAB0-F2E1-8A4A-43F7E109C019}"/>
               </a:ext>
             </a:extLst>
           </p:cNvPr>
@@ -4564,8 +5768,8 @@
         </p:nvSpPr>
         <p:spPr>
           <a:xfrm>
-            <a:off x="7914968" y="1807043"/>
-            <a:ext cx="6096000" cy="2893100"/>
+            <a:off x="7764043" y="2635046"/>
+            <a:ext cx="6096000" cy="1323439"/>
           </a:xfrm>
           <a:prstGeom prst="rect">
             <a:avLst/>
@@ -4579,14 +5783,104 @@
           <a:lstStyle/>
           <a:p>
             <a:r>
-              <a:rPr lang="en-GB" sz="3200" dirty="0"/>
+              <a:rPr lang="en-US" sz="2000" dirty="0"/>
+              <a:t>• Apache Kafka Producer-Consumer</a:t>
+            </a:r>
+          </a:p>
+          <a:p>
+            <a:r>
+              <a:rPr lang="en-US" sz="2000" dirty="0"/>
+              <a:t>   implementation</a:t>
+            </a:r>
+          </a:p>
+          <a:p>
+            <a:r>
+              <a:rPr lang="en-US" sz="2000" dirty="0"/>
+              <a:t>• Real-time healthcare message </a:t>
+            </a:r>
+          </a:p>
+          <a:p>
+            <a:r>
+              <a:rPr lang="en-US" sz="2000" dirty="0"/>
+              <a:t>   streaming demonstration</a:t>
+            </a:r>
+            <a:endParaRPr lang="en-GB" sz="2000" dirty="0"/>
+          </a:p>
+        </p:txBody>
+      </p:sp>
+    </p:spTree>
+    <p:extLst>
+      <p:ext uri="{BB962C8B-B14F-4D97-AF65-F5344CB8AC3E}">
+        <p14:creationId xmlns:p14="http://schemas.microsoft.com/office/powerpoint/2010/main" val="23292971"/>
+      </p:ext>
+    </p:extLst>
+  </p:cSld>
+  <p:clrMapOvr>
+    <a:masterClrMapping/>
+  </p:clrMapOvr>
+</p:sld>
+</file>
+
+<file path=ppt/slides/slide7.xml><?xml version="1.0" encoding="utf-8"?>
+<p:sld xmlns:a="http://schemas.openxmlformats.org/drawingml/2006/main" xmlns:r="http://schemas.openxmlformats.org/officeDocument/2006/relationships" xmlns:p="http://schemas.openxmlformats.org/presentationml/2006/main">
+  <p:cSld>
+    <p:spTree>
+      <p:nvGrpSpPr>
+        <p:cNvPr id="1" name=""/>
+        <p:cNvGrpSpPr/>
+        <p:nvPr/>
+      </p:nvGrpSpPr>
+      <p:grpSpPr>
+        <a:xfrm>
+          <a:off x="0" y="0"/>
+          <a:ext cx="0" cy="0"/>
+          <a:chOff x="0" y="0"/>
+          <a:chExt cx="0" cy="0"/>
+        </a:xfrm>
+      </p:grpSpPr>
+      <p:sp>
+        <p:nvSpPr>
+          <p:cNvPr id="3" name="TextBox 2">
+            <a:extLst>
+              <a:ext uri="{FF2B5EF4-FFF2-40B4-BE49-F238E27FC236}">
+                <a16:creationId xmlns:a16="http://schemas.microsoft.com/office/drawing/2014/main" id="{28CC4748-A3E2-E458-ABFF-B841450C5EBD}"/>
+              </a:ext>
+            </a:extLst>
+          </p:cNvPr>
+          <p:cNvSpPr txBox="1"/>
+          <p:nvPr/>
+        </p:nvSpPr>
+        <p:spPr>
+          <a:xfrm>
+            <a:off x="8268929" y="1049959"/>
+            <a:ext cx="3657601" cy="4924425"/>
+          </a:xfrm>
+          <a:prstGeom prst="rect">
+            <a:avLst/>
+          </a:prstGeom>
+          <a:noFill/>
+        </p:spPr>
+        <p:txBody>
+          <a:bodyPr wrap="square">
+            <a:spAutoFit/>
+          </a:bodyPr>
+          <a:lstStyle/>
+          <a:p>
+            <a:r>
+              <a:rPr lang="en-GB" sz="3200" b="1" dirty="0"/>
               <a:t>Big Data Processing </a:t>
             </a:r>
           </a:p>
           <a:p>
             <a:r>
-              <a:rPr lang="en-GB" sz="3200" dirty="0"/>
-              <a:t>using PySpark</a:t>
+              <a:rPr lang="en-GB" sz="3200" b="1" dirty="0"/>
+              <a:t>using PySpark &amp;</a:t>
+            </a:r>
+          </a:p>
+          <a:p>
+            <a:r>
+              <a:rPr lang="en-GB" sz="3200" b="1" dirty="0"/>
+              <a:t>Databricks</a:t>
             </a:r>
           </a:p>
           <a:p>
@@ -4595,7 +5889,7 @@
           <a:p>
             <a:r>
               <a:rPr lang="en-GB" sz="2000" dirty="0"/>
-              <a:t>• Processed 5000 healthcare records.</a:t>
+              <a:t>• Processed 5000 healthcare      records.</a:t>
             </a:r>
           </a:p>
           <a:p>
@@ -4621,6 +5915,13 @@
               <a:rPr lang="en-GB" sz="2000" dirty="0"/>
               <a:t>• Enabled scalable big data processing.</a:t>
             </a:r>
+          </a:p>
+          <a:p>
+            <a:r>
+              <a:rPr lang="en-US" sz="2000" dirty="0"/>
+              <a:t>• PySpark workflows validated using Databricks notebooks</a:t>
+            </a:r>
+            <a:endParaRPr lang="en-GB" sz="2000" dirty="0"/>
           </a:p>
         </p:txBody>
       </p:sp>
@@ -4703,7 +6004,7 @@
 </p:sld>
 </file>
 
-<file path=ppt/slides/slide7.xml><?xml version="1.0" encoding="utf-8"?>
+<file path=ppt/slides/slide8.xml><?xml version="1.0" encoding="utf-8"?>
 <p:sld xmlns:a="http://schemas.openxmlformats.org/drawingml/2006/main" xmlns:r="http://schemas.openxmlformats.org/officeDocument/2006/relationships" xmlns:p="http://schemas.openxmlformats.org/presentationml/2006/main">
   <p:cSld>
     <p:spTree>
@@ -4725,6 +6026,107 @@
           <p:cNvPr id="3" name="TextBox 2">
             <a:extLst>
               <a:ext uri="{FF2B5EF4-FFF2-40B4-BE49-F238E27FC236}">
+                <a16:creationId xmlns:a16="http://schemas.microsoft.com/office/drawing/2014/main" id="{4775C524-ED56-081A-F58A-CB89C889FD09}"/>
+              </a:ext>
+            </a:extLst>
+          </p:cNvPr>
+          <p:cNvSpPr txBox="1"/>
+          <p:nvPr/>
+        </p:nvSpPr>
+        <p:spPr>
+          <a:xfrm>
+            <a:off x="3146322" y="6336270"/>
+            <a:ext cx="6096000" cy="369332"/>
+          </a:xfrm>
+          <a:prstGeom prst="rect">
+            <a:avLst/>
+          </a:prstGeom>
+          <a:noFill/>
+        </p:spPr>
+        <p:txBody>
+          <a:bodyPr wrap="square">
+            <a:spAutoFit/>
+          </a:bodyPr>
+          <a:lstStyle/>
+          <a:p>
+            <a:r>
+              <a:rPr lang="en-GB" b="1" dirty="0"/>
+              <a:t>Figure: Databricks Notebook Executing PySpark Processing</a:t>
+            </a:r>
+          </a:p>
+        </p:txBody>
+      </p:sp>
+      <p:pic>
+        <p:nvPicPr>
+          <p:cNvPr id="5" name="Picture 4">
+            <a:extLst>
+              <a:ext uri="{FF2B5EF4-FFF2-40B4-BE49-F238E27FC236}">
+                <a16:creationId xmlns:a16="http://schemas.microsoft.com/office/drawing/2014/main" id="{7F0C07F3-4B1C-2857-FD95-4B3C0DAF06B8}"/>
+              </a:ext>
+            </a:extLst>
+          </p:cNvPr>
+          <p:cNvPicPr>
+            <a:picLocks noChangeAspect="1"/>
+          </p:cNvPicPr>
+          <p:nvPr/>
+        </p:nvPicPr>
+        <p:blipFill>
+          <a:blip r:embed="rId2">
+            <a:extLst>
+              <a:ext uri="{28A0092B-C50C-407E-A947-70E740481C1C}">
+                <a14:useLocalDpi xmlns:a14="http://schemas.microsoft.com/office/drawing/2010/main" val="0"/>
+              </a:ext>
+            </a:extLst>
+          </a:blip>
+          <a:stretch>
+            <a:fillRect/>
+          </a:stretch>
+        </p:blipFill>
+        <p:spPr>
+          <a:xfrm>
+            <a:off x="412954" y="115217"/>
+            <a:ext cx="11051458" cy="6086460"/>
+          </a:xfrm>
+          <a:prstGeom prst="rect">
+            <a:avLst/>
+          </a:prstGeom>
+        </p:spPr>
+      </p:pic>
+    </p:spTree>
+    <p:extLst>
+      <p:ext uri="{BB962C8B-B14F-4D97-AF65-F5344CB8AC3E}">
+        <p14:creationId xmlns:p14="http://schemas.microsoft.com/office/powerpoint/2010/main" val="3776562988"/>
+      </p:ext>
+    </p:extLst>
+  </p:cSld>
+  <p:clrMapOvr>
+    <a:masterClrMapping/>
+  </p:clrMapOvr>
+</p:sld>
+</file>
+
+<file path=ppt/slides/slide9.xml><?xml version="1.0" encoding="utf-8"?>
+<p:sld xmlns:a="http://schemas.openxmlformats.org/drawingml/2006/main" xmlns:r="http://schemas.openxmlformats.org/officeDocument/2006/relationships" xmlns:p="http://schemas.openxmlformats.org/presentationml/2006/main">
+  <p:cSld>
+    <p:spTree>
+      <p:nvGrpSpPr>
+        <p:cNvPr id="1" name=""/>
+        <p:cNvGrpSpPr/>
+        <p:nvPr/>
+      </p:nvGrpSpPr>
+      <p:grpSpPr>
+        <a:xfrm>
+          <a:off x="0" y="0"/>
+          <a:ext cx="0" cy="0"/>
+          <a:chOff x="0" y="0"/>
+          <a:chExt cx="0" cy="0"/>
+        </a:xfrm>
+      </p:grpSpPr>
+      <p:sp>
+        <p:nvSpPr>
+          <p:cNvPr id="3" name="TextBox 2">
+            <a:extLst>
+              <a:ext uri="{FF2B5EF4-FFF2-40B4-BE49-F238E27FC236}">
                 <a16:creationId xmlns:a16="http://schemas.microsoft.com/office/drawing/2014/main" id="{186C71BE-82D2-6080-76CD-F4BD40D7DFAB}"/>
               </a:ext>
             </a:extLst>
@@ -4749,13 +6151,13 @@
           <a:lstStyle/>
           <a:p>
             <a:r>
-              <a:rPr lang="en-GB" sz="3200" dirty="0"/>
+              <a:rPr lang="en-GB" sz="3200" b="1" dirty="0"/>
               <a:t>AWS RDS &amp; </a:t>
             </a:r>
           </a:p>
           <a:p>
             <a:r>
-              <a:rPr lang="en-GB" sz="3200" dirty="0"/>
+              <a:rPr lang="en-GB" sz="3200" b="1" dirty="0"/>
               <a:t>Data Warehouse</a:t>
             </a:r>
           </a:p>
@@ -4924,328 +6326,6 @@
     <p:extLst>
       <p:ext uri="{BB962C8B-B14F-4D97-AF65-F5344CB8AC3E}">
         <p14:creationId xmlns:p14="http://schemas.microsoft.com/office/powerpoint/2010/main" val="574445657"/>
-      </p:ext>
-    </p:extLst>
-  </p:cSld>
-  <p:clrMapOvr>
-    <a:masterClrMapping/>
-  </p:clrMapOvr>
-</p:sld>
-</file>
-
-<file path=ppt/slides/slide8.xml><?xml version="1.0" encoding="utf-8"?>
-<p:sld xmlns:a="http://schemas.openxmlformats.org/drawingml/2006/main" xmlns:r="http://schemas.openxmlformats.org/officeDocument/2006/relationships" xmlns:p="http://schemas.openxmlformats.org/presentationml/2006/main">
-  <p:cSld>
-    <p:spTree>
-      <p:nvGrpSpPr>
-        <p:cNvPr id="1" name=""/>
-        <p:cNvGrpSpPr/>
-        <p:nvPr/>
-      </p:nvGrpSpPr>
-      <p:grpSpPr>
-        <a:xfrm>
-          <a:off x="0" y="0"/>
-          <a:ext cx="0" cy="0"/>
-          <a:chOff x="0" y="0"/>
-          <a:chExt cx="0" cy="0"/>
-        </a:xfrm>
-      </p:grpSpPr>
-      <p:sp>
-        <p:nvSpPr>
-          <p:cNvPr id="3" name="TextBox 2">
-            <a:extLst>
-              <a:ext uri="{FF2B5EF4-FFF2-40B4-BE49-F238E27FC236}">
-                <a16:creationId xmlns:a16="http://schemas.microsoft.com/office/drawing/2014/main" id="{9E4477BC-B009-9F2D-792B-5ABADDF67C8C}"/>
-              </a:ext>
-            </a:extLst>
-          </p:cNvPr>
-          <p:cNvSpPr txBox="1"/>
-          <p:nvPr/>
-        </p:nvSpPr>
-        <p:spPr>
-          <a:xfrm>
-            <a:off x="7639665" y="2396131"/>
-            <a:ext cx="6096000" cy="2400657"/>
-          </a:xfrm>
-          <a:prstGeom prst="rect">
-            <a:avLst/>
-          </a:prstGeom>
-          <a:noFill/>
-        </p:spPr>
-        <p:txBody>
-          <a:bodyPr wrap="square">
-            <a:spAutoFit/>
-          </a:bodyPr>
-          <a:lstStyle/>
-          <a:p>
-            <a:r>
-              <a:rPr lang="en-GB" sz="3200" dirty="0"/>
-              <a:t>Exploratory Data Analysis</a:t>
-            </a:r>
-          </a:p>
-          <a:p>
-            <a:endParaRPr lang="en-GB" dirty="0"/>
-          </a:p>
-          <a:p>
-            <a:r>
-              <a:rPr lang="en-GB" sz="2000" dirty="0"/>
-              <a:t>• Disease distribution analysis.</a:t>
-            </a:r>
-          </a:p>
-          <a:p>
-            <a:r>
-              <a:rPr lang="en-GB" sz="2000" dirty="0"/>
-              <a:t>• Gender and city-wise analysis.</a:t>
-            </a:r>
-          </a:p>
-          <a:p>
-            <a:r>
-              <a:rPr lang="en-GB" sz="2000" dirty="0"/>
-              <a:t>• Admission status analysis.</a:t>
-            </a:r>
-          </a:p>
-          <a:p>
-            <a:r>
-              <a:rPr lang="en-GB" sz="2000" dirty="0"/>
-              <a:t>• Treatment cost statistics.</a:t>
-            </a:r>
-          </a:p>
-          <a:p>
-            <a:r>
-              <a:rPr lang="en-GB" sz="2000" dirty="0"/>
-              <a:t>• Generated healthcare insights.</a:t>
-            </a:r>
-          </a:p>
-        </p:txBody>
-      </p:sp>
-      <p:pic>
-        <p:nvPicPr>
-          <p:cNvPr id="5" name="Picture 4">
-            <a:extLst>
-              <a:ext uri="{FF2B5EF4-FFF2-40B4-BE49-F238E27FC236}">
-                <a16:creationId xmlns:a16="http://schemas.microsoft.com/office/drawing/2014/main" id="{AB95E666-E490-C7ED-937D-DC532D93691F}"/>
-              </a:ext>
-            </a:extLst>
-          </p:cNvPr>
-          <p:cNvPicPr>
-            <a:picLocks noChangeAspect="1"/>
-          </p:cNvPicPr>
-          <p:nvPr/>
-        </p:nvPicPr>
-        <p:blipFill>
-          <a:blip r:embed="rId2">
-            <a:extLst>
-              <a:ext uri="{28A0092B-C50C-407E-A947-70E740481C1C}">
-                <a14:useLocalDpi xmlns:a14="http://schemas.microsoft.com/office/drawing/2010/main" val="0"/>
-              </a:ext>
-            </a:extLst>
-          </a:blip>
-          <a:stretch>
-            <a:fillRect/>
-          </a:stretch>
-        </p:blipFill>
-        <p:spPr>
-          <a:xfrm>
-            <a:off x="168130" y="247650"/>
-            <a:ext cx="7373211" cy="6362700"/>
-          </a:xfrm>
-          <a:prstGeom prst="rect">
-            <a:avLst/>
-          </a:prstGeom>
-          <a:solidFill>
-            <a:srgbClr val="FFFFFF">
-              <a:shade val="85000"/>
-            </a:srgbClr>
-          </a:solidFill>
-          <a:ln w="88900" cap="sq">
-            <a:solidFill>
-              <a:srgbClr val="FFFFFF"/>
-            </a:solidFill>
-            <a:miter lim="800000"/>
-          </a:ln>
-          <a:effectLst>
-            <a:outerShdw blurRad="55000" dist="18000" dir="5400000" algn="tl" rotWithShape="0">
-              <a:srgbClr val="000000">
-                <a:alpha val="40000"/>
-              </a:srgbClr>
-            </a:outerShdw>
-          </a:effectLst>
-          <a:scene3d>
-            <a:camera prst="orthographicFront"/>
-            <a:lightRig rig="twoPt" dir="t">
-              <a:rot lat="0" lon="0" rev="7200000"/>
-            </a:lightRig>
-          </a:scene3d>
-          <a:sp3d>
-            <a:bevelT w="25400" h="19050"/>
-            <a:contourClr>
-              <a:srgbClr val="FFFFFF"/>
-            </a:contourClr>
-          </a:sp3d>
-        </p:spPr>
-      </p:pic>
-    </p:spTree>
-    <p:extLst>
-      <p:ext uri="{BB962C8B-B14F-4D97-AF65-F5344CB8AC3E}">
-        <p14:creationId xmlns:p14="http://schemas.microsoft.com/office/powerpoint/2010/main" val="1555976044"/>
-      </p:ext>
-    </p:extLst>
-  </p:cSld>
-  <p:clrMapOvr>
-    <a:masterClrMapping/>
-  </p:clrMapOvr>
-</p:sld>
-</file>
-
-<file path=ppt/slides/slide9.xml><?xml version="1.0" encoding="utf-8"?>
-<p:sld xmlns:a="http://schemas.openxmlformats.org/drawingml/2006/main" xmlns:r="http://schemas.openxmlformats.org/officeDocument/2006/relationships" xmlns:p="http://schemas.openxmlformats.org/presentationml/2006/main">
-  <p:cSld>
-    <p:spTree>
-      <p:nvGrpSpPr>
-        <p:cNvPr id="1" name=""/>
-        <p:cNvGrpSpPr/>
-        <p:nvPr/>
-      </p:nvGrpSpPr>
-      <p:grpSpPr>
-        <a:xfrm>
-          <a:off x="0" y="0"/>
-          <a:ext cx="0" cy="0"/>
-          <a:chOff x="0" y="0"/>
-          <a:chExt cx="0" cy="0"/>
-        </a:xfrm>
-      </p:grpSpPr>
-      <p:sp>
-        <p:nvSpPr>
-          <p:cNvPr id="3" name="TextBox 2">
-            <a:extLst>
-              <a:ext uri="{FF2B5EF4-FFF2-40B4-BE49-F238E27FC236}">
-                <a16:creationId xmlns:a16="http://schemas.microsoft.com/office/drawing/2014/main" id="{4BB448C2-9C61-238F-4940-6D285C14ED9C}"/>
-              </a:ext>
-            </a:extLst>
-          </p:cNvPr>
-          <p:cNvSpPr txBox="1"/>
-          <p:nvPr/>
-        </p:nvSpPr>
-        <p:spPr>
-          <a:xfrm>
-            <a:off x="117987" y="3861984"/>
-            <a:ext cx="11541474" cy="2092881"/>
-          </a:xfrm>
-          <a:prstGeom prst="rect">
-            <a:avLst/>
-          </a:prstGeom>
-          <a:noFill/>
-        </p:spPr>
-        <p:txBody>
-          <a:bodyPr wrap="square">
-            <a:spAutoFit/>
-          </a:bodyPr>
-          <a:lstStyle/>
-          <a:p>
-            <a:r>
-              <a:rPr lang="en-GB" sz="3200" dirty="0"/>
-              <a:t>Machine Learning Model</a:t>
-            </a:r>
-          </a:p>
-          <a:p>
-            <a:endParaRPr lang="en-GB" dirty="0"/>
-          </a:p>
-          <a:p>
-            <a:r>
-              <a:rPr lang="en-GB" sz="2000" dirty="0"/>
-              <a:t>• Random Forest Regressor implemented.</a:t>
-            </a:r>
-          </a:p>
-          <a:p>
-            <a:r>
-              <a:rPr lang="en-GB" sz="2000" dirty="0"/>
-              <a:t>• Treatment cost prediction performed.</a:t>
-            </a:r>
-          </a:p>
-          <a:p>
-            <a:r>
-              <a:rPr lang="en-GB" sz="2000" dirty="0"/>
-              <a:t>• Model trained on healthcare dataset.</a:t>
-            </a:r>
-          </a:p>
-          <a:p>
-            <a:r>
-              <a:rPr lang="en-GB" sz="2000" dirty="0"/>
-              <a:t>• Performance evaluated using MAE.</a:t>
-            </a:r>
-          </a:p>
-        </p:txBody>
-      </p:sp>
-      <p:pic>
-        <p:nvPicPr>
-          <p:cNvPr id="5" name="Picture 4">
-            <a:extLst>
-              <a:ext uri="{FF2B5EF4-FFF2-40B4-BE49-F238E27FC236}">
-                <a16:creationId xmlns:a16="http://schemas.microsoft.com/office/drawing/2014/main" id="{A5D5C314-CBCF-CD42-FD1D-5ED2C119DB95}"/>
-              </a:ext>
-            </a:extLst>
-          </p:cNvPr>
-          <p:cNvPicPr>
-            <a:picLocks noChangeAspect="1"/>
-          </p:cNvPicPr>
-          <p:nvPr/>
-        </p:nvPicPr>
-        <p:blipFill>
-          <a:blip r:embed="rId2">
-            <a:extLst>
-              <a:ext uri="{28A0092B-C50C-407E-A947-70E740481C1C}">
-                <a14:useLocalDpi xmlns:a14="http://schemas.microsoft.com/office/drawing/2010/main" val="0"/>
-              </a:ext>
-            </a:extLst>
-          </a:blip>
-          <a:stretch>
-            <a:fillRect/>
-          </a:stretch>
-        </p:blipFill>
-        <p:spPr>
-          <a:xfrm>
-            <a:off x="286733" y="286035"/>
-            <a:ext cx="11472648" cy="3314700"/>
-          </a:xfrm>
-          <a:prstGeom prst="rect">
-            <a:avLst/>
-          </a:prstGeom>
-          <a:solidFill>
-            <a:srgbClr val="FFFFFF">
-              <a:shade val="85000"/>
-            </a:srgbClr>
-          </a:solidFill>
-          <a:ln w="88900" cap="sq">
-            <a:solidFill>
-              <a:srgbClr val="FFFFFF"/>
-            </a:solidFill>
-            <a:miter lim="800000"/>
-          </a:ln>
-          <a:effectLst>
-            <a:outerShdw blurRad="55000" dist="18000" dir="5400000" algn="tl" rotWithShape="0">
-              <a:srgbClr val="000000">
-                <a:alpha val="40000"/>
-              </a:srgbClr>
-            </a:outerShdw>
-          </a:effectLst>
-          <a:scene3d>
-            <a:camera prst="orthographicFront"/>
-            <a:lightRig rig="twoPt" dir="t">
-              <a:rot lat="0" lon="0" rev="7200000"/>
-            </a:lightRig>
-          </a:scene3d>
-          <a:sp3d>
-            <a:bevelT w="25400" h="19050"/>
-            <a:contourClr>
-              <a:srgbClr val="FFFFFF"/>
-            </a:contourClr>
-          </a:sp3d>
-        </p:spPr>
-      </p:pic>
-    </p:spTree>
-    <p:extLst>
-      <p:ext uri="{BB962C8B-B14F-4D97-AF65-F5344CB8AC3E}">
-        <p14:creationId xmlns:p14="http://schemas.microsoft.com/office/powerpoint/2010/main" val="2032054767"/>
       </p:ext>
     </p:extLst>
   </p:cSld>
@@ -5548,4 +6628,299 @@
     </a:ext>
   </a:extLst>
 </a:theme>
+</file>
+
+<file path=ppt/theme/theme2.xml><?xml version="1.0" encoding="utf-8"?>
+<a:theme xmlns:a="http://schemas.openxmlformats.org/drawingml/2006/main" name="Office Theme">
+  <a:themeElements>
+    <a:clrScheme name="Office">
+      <a:dk1>
+        <a:sysClr val="windowText" lastClr="000000"/>
+      </a:dk1>
+      <a:lt1>
+        <a:sysClr val="window" lastClr="FFFFFF"/>
+      </a:lt1>
+      <a:dk2>
+        <a:srgbClr val="44546A"/>
+      </a:dk2>
+      <a:lt2>
+        <a:srgbClr val="E7E6E6"/>
+      </a:lt2>
+      <a:accent1>
+        <a:srgbClr val="4472C4"/>
+      </a:accent1>
+      <a:accent2>
+        <a:srgbClr val="ED7D31"/>
+      </a:accent2>
+      <a:accent3>
+        <a:srgbClr val="A5A5A5"/>
+      </a:accent3>
+      <a:accent4>
+        <a:srgbClr val="FFC000"/>
+      </a:accent4>
+      <a:accent5>
+        <a:srgbClr val="5B9BD5"/>
+      </a:accent5>
+      <a:accent6>
+        <a:srgbClr val="70AD47"/>
+      </a:accent6>
+      <a:hlink>
+        <a:srgbClr val="0563C1"/>
+      </a:hlink>
+      <a:folHlink>
+        <a:srgbClr val="954F72"/>
+      </a:folHlink>
+    </a:clrScheme>
+    <a:fontScheme name="Office">
+      <a:majorFont>
+        <a:latin typeface="Calibri Light" panose="020F0302020204030204"/>
+        <a:ea typeface=""/>
+        <a:cs typeface=""/>
+        <a:font script="Jpan" typeface="游ゴシック Light"/>
+        <a:font script="Hang" typeface="맑은 고딕"/>
+        <a:font script="Hans" typeface="等线 Light"/>
+        <a:font script="Hant" typeface="新細明體"/>
+        <a:font script="Arab" typeface="Times New Roman"/>
+        <a:font script="Hebr" typeface="Times New Roman"/>
+        <a:font script="Thai" typeface="Angsana New"/>
+        <a:font script="Ethi" typeface="Nyala"/>
+        <a:font script="Beng" typeface="Vrinda"/>
+        <a:font script="Gujr" typeface="Shruti"/>
+        <a:font script="Khmr" typeface="MoolBoran"/>
+        <a:font script="Knda" typeface="Tunga"/>
+        <a:font script="Guru" typeface="Raavi"/>
+        <a:font script="Cans" typeface="Euphemia"/>
+        <a:font script="Cher" typeface="Plantagenet Cherokee"/>
+        <a:font script="Yiii" typeface="Microsoft Yi Baiti"/>
+        <a:font script="Tibt" typeface="Microsoft Himalaya"/>
+        <a:font script="Thaa" typeface="MV Boli"/>
+        <a:font script="Deva" typeface="Mangal"/>
+        <a:font script="Telu" typeface="Gautami"/>
+        <a:font script="Taml" typeface="Latha"/>
+        <a:font script="Syrc" typeface="Estrangelo Edessa"/>
+        <a:font script="Orya" typeface="Kalinga"/>
+        <a:font script="Mlym" typeface="Kartika"/>
+        <a:font script="Laoo" typeface="DokChampa"/>
+        <a:font script="Sinh" typeface="Iskoola Pota"/>
+        <a:font script="Mong" typeface="Mongolian Baiti"/>
+        <a:font script="Viet" typeface="Times New Roman"/>
+        <a:font script="Uigh" typeface="Microsoft Uighur"/>
+        <a:font script="Geor" typeface="Sylfaen"/>
+        <a:font script="Armn" typeface="Arial"/>
+        <a:font script="Bugi" typeface="Leelawadee UI"/>
+        <a:font script="Bopo" typeface="Microsoft JhengHei"/>
+        <a:font script="Java" typeface="Javanese Text"/>
+        <a:font script="Lisu" typeface="Segoe UI"/>
+        <a:font script="Mymr" typeface="Myanmar Text"/>
+        <a:font script="Nkoo" typeface="Ebrima"/>
+        <a:font script="Olck" typeface="Nirmala UI"/>
+        <a:font script="Osma" typeface="Ebrima"/>
+        <a:font script="Phag" typeface="Phagspa"/>
+        <a:font script="Syrn" typeface="Estrangelo Edessa"/>
+        <a:font script="Syrj" typeface="Estrangelo Edessa"/>
+        <a:font script="Syre" typeface="Estrangelo Edessa"/>
+        <a:font script="Sora" typeface="Nirmala UI"/>
+        <a:font script="Tale" typeface="Microsoft Tai Le"/>
+        <a:font script="Talu" typeface="Microsoft New Tai Lue"/>
+        <a:font script="Tfng" typeface="Ebrima"/>
+      </a:majorFont>
+      <a:minorFont>
+        <a:latin typeface="Calibri" panose="020F0502020204030204"/>
+        <a:ea typeface=""/>
+        <a:cs typeface=""/>
+        <a:font script="Jpan" typeface="游ゴシック"/>
+        <a:font script="Hang" typeface="맑은 고딕"/>
+        <a:font script="Hans" typeface="等线"/>
+        <a:font script="Hant" typeface="新細明體"/>
+        <a:font script="Arab" typeface="Arial"/>
+        <a:font script="Hebr" typeface="Arial"/>
+        <a:font script="Thai" typeface="Cordia New"/>
+        <a:font script="Ethi" typeface="Nyala"/>
+        <a:font script="Beng" typeface="Vrinda"/>
+        <a:font script="Gujr" typeface="Shruti"/>
+        <a:font script="Khmr" typeface="DaunPenh"/>
+        <a:font script="Knda" typeface="Tunga"/>
+        <a:font script="Guru" typeface="Raavi"/>
+        <a:font script="Cans" typeface="Euphemia"/>
+        <a:font script="Cher" typeface="Plantagenet Cherokee"/>
+        <a:font script="Yiii" typeface="Microsoft Yi Baiti"/>
+        <a:font script="Tibt" typeface="Microsoft Himalaya"/>
+        <a:font script="Thaa" typeface="MV Boli"/>
+        <a:font script="Deva" typeface="Mangal"/>
+        <a:font script="Telu" typeface="Gautami"/>
+        <a:font script="Taml" typeface="Latha"/>
+        <a:font script="Syrc" typeface="Estrangelo Edessa"/>
+        <a:font script="Orya" typeface="Kalinga"/>
+        <a:font script="Mlym" typeface="Kartika"/>
+        <a:font script="Laoo" typeface="DokChampa"/>
+        <a:font script="Sinh" typeface="Iskoola Pota"/>
+        <a:font script="Mong" typeface="Mongolian Baiti"/>
+        <a:font script="Viet" typeface="Arial"/>
+        <a:font script="Uigh" typeface="Microsoft Uighur"/>
+        <a:font script="Geor" typeface="Sylfaen"/>
+        <a:font script="Armn" typeface="Arial"/>
+        <a:font script="Bugi" typeface="Leelawadee UI"/>
+        <a:font script="Bopo" typeface="Microsoft JhengHei"/>
+        <a:font script="Java" typeface="Javanese Text"/>
+        <a:font script="Lisu" typeface="Segoe UI"/>
+        <a:font script="Mymr" typeface="Myanmar Text"/>
+        <a:font script="Nkoo" typeface="Ebrima"/>
+        <a:font script="Olck" typeface="Nirmala UI"/>
+        <a:font script="Osma" typeface="Ebrima"/>
+        <a:font script="Phag" typeface="Phagspa"/>
+        <a:font script="Syrn" typeface="Estrangelo Edessa"/>
+        <a:font script="Syrj" typeface="Estrangelo Edessa"/>
+        <a:font script="Syre" typeface="Estrangelo Edessa"/>
+        <a:font script="Sora" typeface="Nirmala UI"/>
+        <a:font script="Tale" typeface="Microsoft Tai Le"/>
+        <a:font script="Talu" typeface="Microsoft New Tai Lue"/>
+        <a:font script="Tfng" typeface="Ebrima"/>
+      </a:minorFont>
+    </a:fontScheme>
+    <a:fmtScheme name="Office">
+      <a:fillStyleLst>
+        <a:solidFill>
+          <a:schemeClr val="phClr"/>
+        </a:solidFill>
+        <a:gradFill rotWithShape="1">
+          <a:gsLst>
+            <a:gs pos="0">
+              <a:schemeClr val="phClr">
+                <a:lumMod val="110000"/>
+                <a:satMod val="105000"/>
+                <a:tint val="67000"/>
+              </a:schemeClr>
+            </a:gs>
+            <a:gs pos="50000">
+              <a:schemeClr val="phClr">
+                <a:lumMod val="105000"/>
+                <a:satMod val="103000"/>
+                <a:tint val="73000"/>
+              </a:schemeClr>
+            </a:gs>
+            <a:gs pos="100000">
+              <a:schemeClr val="phClr">
+                <a:lumMod val="105000"/>
+                <a:satMod val="109000"/>
+                <a:tint val="81000"/>
+              </a:schemeClr>
+            </a:gs>
+          </a:gsLst>
+          <a:lin ang="5400000" scaled="0"/>
+        </a:gradFill>
+        <a:gradFill rotWithShape="1">
+          <a:gsLst>
+            <a:gs pos="0">
+              <a:schemeClr val="phClr">
+                <a:satMod val="103000"/>
+                <a:lumMod val="102000"/>
+                <a:tint val="94000"/>
+              </a:schemeClr>
+            </a:gs>
+            <a:gs pos="50000">
+              <a:schemeClr val="phClr">
+                <a:satMod val="110000"/>
+                <a:lumMod val="100000"/>
+                <a:shade val="100000"/>
+              </a:schemeClr>
+            </a:gs>
+            <a:gs pos="100000">
+              <a:schemeClr val="phClr">
+                <a:lumMod val="99000"/>
+                <a:satMod val="120000"/>
+                <a:shade val="78000"/>
+              </a:schemeClr>
+            </a:gs>
+          </a:gsLst>
+          <a:lin ang="5400000" scaled="0"/>
+        </a:gradFill>
+      </a:fillStyleLst>
+      <a:lnStyleLst>
+        <a:ln w="6350" cap="flat" cmpd="sng" algn="ctr">
+          <a:solidFill>
+            <a:schemeClr val="phClr"/>
+          </a:solidFill>
+          <a:prstDash val="solid"/>
+          <a:miter lim="800000"/>
+        </a:ln>
+        <a:ln w="12700" cap="flat" cmpd="sng" algn="ctr">
+          <a:solidFill>
+            <a:schemeClr val="phClr"/>
+          </a:solidFill>
+          <a:prstDash val="solid"/>
+          <a:miter lim="800000"/>
+        </a:ln>
+        <a:ln w="19050" cap="flat" cmpd="sng" algn="ctr">
+          <a:solidFill>
+            <a:schemeClr val="phClr"/>
+          </a:solidFill>
+          <a:prstDash val="solid"/>
+          <a:miter lim="800000"/>
+        </a:ln>
+      </a:lnStyleLst>
+      <a:effectStyleLst>
+        <a:effectStyle>
+          <a:effectLst/>
+        </a:effectStyle>
+        <a:effectStyle>
+          <a:effectLst/>
+        </a:effectStyle>
+        <a:effectStyle>
+          <a:effectLst>
+            <a:outerShdw blurRad="57150" dist="19050" dir="5400000" algn="ctr" rotWithShape="0">
+              <a:srgbClr val="000000">
+                <a:alpha val="63000"/>
+              </a:srgbClr>
+            </a:outerShdw>
+          </a:effectLst>
+        </a:effectStyle>
+      </a:effectStyleLst>
+      <a:bgFillStyleLst>
+        <a:solidFill>
+          <a:schemeClr val="phClr"/>
+        </a:solidFill>
+        <a:solidFill>
+          <a:schemeClr val="phClr">
+            <a:tint val="95000"/>
+            <a:satMod val="170000"/>
+          </a:schemeClr>
+        </a:solidFill>
+        <a:gradFill rotWithShape="1">
+          <a:gsLst>
+            <a:gs pos="0">
+              <a:schemeClr val="phClr">
+                <a:tint val="93000"/>
+                <a:satMod val="150000"/>
+                <a:shade val="98000"/>
+                <a:lumMod val="102000"/>
+              </a:schemeClr>
+            </a:gs>
+            <a:gs pos="50000">
+              <a:schemeClr val="phClr">
+                <a:tint val="98000"/>
+                <a:satMod val="130000"/>
+                <a:shade val="90000"/>
+                <a:lumMod val="103000"/>
+              </a:schemeClr>
+            </a:gs>
+            <a:gs pos="100000">
+              <a:schemeClr val="phClr">
+                <a:shade val="63000"/>
+                <a:satMod val="120000"/>
+              </a:schemeClr>
+            </a:gs>
+          </a:gsLst>
+          <a:lin ang="5400000" scaled="0"/>
+        </a:gradFill>
+      </a:bgFillStyleLst>
+    </a:fmtScheme>
+  </a:themeElements>
+  <a:objectDefaults/>
+  <a:extraClrSchemeLst/>
+  <a:extLst>
+    <a:ext uri="{05A4C25C-085E-4340-85A3-A5531E510DB2}">
+      <thm15:themeFamily xmlns:thm15="http://schemas.microsoft.com/office/thememl/2012/main" name="Office Theme" id="{62F939B6-93AF-4DB8-9C6B-D6C7DFDC589F}" vid="{4A3C46E8-61CC-4603-A589-7422A47A8E4A}"/>
+    </a:ext>
+  </a:extLst>
+</a:theme>
 </file>
</xml_diff>

<commit_message>
Update final capstone presentation slides
Uploaded the final version of the IIT Jodhpur PGDDE Capstone Project presentation, including updated cover slide, project architecture, key results, conclusion, future scope, and final formatting revisions.
</commit_message>
<xml_diff>
--- a/docs/docs/PGDDE_Capstone_Healthcare_Analytics_Pipeline_IITJ.pptx
+++ b/docs/docs/PGDDE_Capstone_Healthcare_Analytics_Pipeline_IITJ.pptx
@@ -5,7 +5,7 @@
     <p:sldMasterId id="2147483648" r:id="rId1"/>
   </p:sldMasterIdLst>
   <p:notesMasterIdLst>
-    <p:notesMasterId r:id="rId16"/>
+    <p:notesMasterId r:id="rId17"/>
   </p:notesMasterIdLst>
   <p:sldIdLst>
     <p:sldId id="256" r:id="rId2"/>
@@ -21,7 +21,8 @@
     <p:sldId id="264" r:id="rId12"/>
     <p:sldId id="269" r:id="rId13"/>
     <p:sldId id="265" r:id="rId14"/>
-    <p:sldId id="266" r:id="rId15"/>
+    <p:sldId id="270" r:id="rId15"/>
+    <p:sldId id="271" r:id="rId16"/>
   </p:sldIdLst>
   <p:sldSz cx="12192000" cy="6858000"/>
   <p:notesSz cx="6858000" cy="9144000"/>
@@ -210,7 +211,7 @@
           <a:p>
             <a:fld id="{6CAD6177-CAEF-4E70-8DEE-78C553712586}" type="datetimeFigureOut">
               <a:rPr lang="en-GB" smtClean="0"/>
-              <a:t>31/05/2026</a:t>
+              <a:t>03/07/2026</a:t>
             </a:fld>
             <a:endParaRPr lang="en-GB"/>
           </a:p>
@@ -711,7 +712,7 @@
           <a:p>
             <a:fld id="{8727B1B5-114F-462F-9F43-A96471EB3E77}" type="datetimeFigureOut">
               <a:rPr lang="en-GB" smtClean="0"/>
-              <a:t>31/05/2026</a:t>
+              <a:t>03/07/2026</a:t>
             </a:fld>
             <a:endParaRPr lang="en-GB"/>
           </a:p>
@@ -911,7 +912,7 @@
           <a:p>
             <a:fld id="{8727B1B5-114F-462F-9F43-A96471EB3E77}" type="datetimeFigureOut">
               <a:rPr lang="en-GB" smtClean="0"/>
-              <a:t>31/05/2026</a:t>
+              <a:t>03/07/2026</a:t>
             </a:fld>
             <a:endParaRPr lang="en-GB"/>
           </a:p>
@@ -1121,7 +1122,7 @@
           <a:p>
             <a:fld id="{8727B1B5-114F-462F-9F43-A96471EB3E77}" type="datetimeFigureOut">
               <a:rPr lang="en-GB" smtClean="0"/>
-              <a:t>31/05/2026</a:t>
+              <a:t>03/07/2026</a:t>
             </a:fld>
             <a:endParaRPr lang="en-GB"/>
           </a:p>
@@ -1321,7 +1322,7 @@
           <a:p>
             <a:fld id="{8727B1B5-114F-462F-9F43-A96471EB3E77}" type="datetimeFigureOut">
               <a:rPr lang="en-GB" smtClean="0"/>
-              <a:t>31/05/2026</a:t>
+              <a:t>03/07/2026</a:t>
             </a:fld>
             <a:endParaRPr lang="en-GB"/>
           </a:p>
@@ -1597,7 +1598,7 @@
           <a:p>
             <a:fld id="{8727B1B5-114F-462F-9F43-A96471EB3E77}" type="datetimeFigureOut">
               <a:rPr lang="en-GB" smtClean="0"/>
-              <a:t>31/05/2026</a:t>
+              <a:t>03/07/2026</a:t>
             </a:fld>
             <a:endParaRPr lang="en-GB"/>
           </a:p>
@@ -1865,7 +1866,7 @@
           <a:p>
             <a:fld id="{8727B1B5-114F-462F-9F43-A96471EB3E77}" type="datetimeFigureOut">
               <a:rPr lang="en-GB" smtClean="0"/>
-              <a:t>31/05/2026</a:t>
+              <a:t>03/07/2026</a:t>
             </a:fld>
             <a:endParaRPr lang="en-GB"/>
           </a:p>
@@ -2280,7 +2281,7 @@
           <a:p>
             <a:fld id="{8727B1B5-114F-462F-9F43-A96471EB3E77}" type="datetimeFigureOut">
               <a:rPr lang="en-GB" smtClean="0"/>
-              <a:t>31/05/2026</a:t>
+              <a:t>03/07/2026</a:t>
             </a:fld>
             <a:endParaRPr lang="en-GB"/>
           </a:p>
@@ -2422,7 +2423,7 @@
           <a:p>
             <a:fld id="{8727B1B5-114F-462F-9F43-A96471EB3E77}" type="datetimeFigureOut">
               <a:rPr lang="en-GB" smtClean="0"/>
-              <a:t>31/05/2026</a:t>
+              <a:t>03/07/2026</a:t>
             </a:fld>
             <a:endParaRPr lang="en-GB"/>
           </a:p>
@@ -2535,7 +2536,7 @@
           <a:p>
             <a:fld id="{8727B1B5-114F-462F-9F43-A96471EB3E77}" type="datetimeFigureOut">
               <a:rPr lang="en-GB" smtClean="0"/>
-              <a:t>31/05/2026</a:t>
+              <a:t>03/07/2026</a:t>
             </a:fld>
             <a:endParaRPr lang="en-GB"/>
           </a:p>
@@ -2848,7 +2849,7 @@
           <a:p>
             <a:fld id="{8727B1B5-114F-462F-9F43-A96471EB3E77}" type="datetimeFigureOut">
               <a:rPr lang="en-GB" smtClean="0"/>
-              <a:t>31/05/2026</a:t>
+              <a:t>03/07/2026</a:t>
             </a:fld>
             <a:endParaRPr lang="en-GB"/>
           </a:p>
@@ -3137,7 +3138,7 @@
           <a:p>
             <a:fld id="{8727B1B5-114F-462F-9F43-A96471EB3E77}" type="datetimeFigureOut">
               <a:rPr lang="en-GB" smtClean="0"/>
-              <a:t>31/05/2026</a:t>
+              <a:t>03/07/2026</a:t>
             </a:fld>
             <a:endParaRPr lang="en-GB"/>
           </a:p>
@@ -3380,7 +3381,7 @@
           <a:p>
             <a:fld id="{8727B1B5-114F-462F-9F43-A96471EB3E77}" type="datetimeFigureOut">
               <a:rPr lang="en-GB" smtClean="0"/>
-              <a:t>31/05/2026</a:t>
+              <a:t>03/07/2026</a:t>
             </a:fld>
             <a:endParaRPr lang="en-GB"/>
           </a:p>
@@ -3799,146 +3800,179 @@
       </p:grpSpPr>
       <p:sp>
         <p:nvSpPr>
-          <p:cNvPr id="2" name="Title 1">
-            <a:extLst>
-              <a:ext uri="{FF2B5EF4-FFF2-40B4-BE49-F238E27FC236}">
-                <a16:creationId xmlns:a16="http://schemas.microsoft.com/office/drawing/2014/main" id="{A4440CD0-CA02-870A-881E-AD5144EEA67A}"/>
-              </a:ext>
-            </a:extLst>
-          </p:cNvPr>
-          <p:cNvSpPr>
-            <a:spLocks noGrp="1"/>
-          </p:cNvSpPr>
-          <p:nvPr>
-            <p:ph type="ctrTitle"/>
-          </p:nvPr>
+          <p:cNvPr id="5" name="TextBox 4">
+            <a:extLst>
+              <a:ext uri="{FF2B5EF4-FFF2-40B4-BE49-F238E27FC236}">
+                <a16:creationId xmlns:a16="http://schemas.microsoft.com/office/drawing/2014/main" id="{00AF4E55-95E3-77DF-B8A5-BB8837685860}"/>
+              </a:ext>
+            </a:extLst>
+          </p:cNvPr>
+          <p:cNvSpPr txBox="1"/>
+          <p:nvPr/>
         </p:nvSpPr>
         <p:spPr>
           <a:xfrm>
-            <a:off x="1386348" y="558467"/>
-            <a:ext cx="9144000" cy="1217714"/>
+            <a:off x="0" y="547324"/>
+            <a:ext cx="12191999" cy="892552"/>
           </a:xfrm>
+          <a:prstGeom prst="rect">
+            <a:avLst/>
+          </a:prstGeom>
+          <a:noFill/>
         </p:spPr>
         <p:txBody>
-          <a:bodyPr>
-            <a:normAutofit/>
+          <a:bodyPr wrap="square">
+            <a:spAutoFit/>
           </a:bodyPr>
           <a:lstStyle/>
           <a:p>
-            <a:pPr algn="l"/>
-            <a:r>
-              <a:rPr lang="en-GB" sz="4000" b="1" dirty="0"/>
-              <a:t>Healthcare Analytics Pipeline Project</a:t>
-            </a:r>
-            <a:br>
-              <a:rPr lang="en-GB" sz="4000" b="1" dirty="0"/>
-            </a:br>
-            <a:r>
-              <a:rPr lang="en-GB" sz="4000" b="1" dirty="0"/>
-              <a:t>for Medicare Hospital</a:t>
-            </a:r>
-          </a:p>
-        </p:txBody>
-      </p:sp>
-      <p:sp>
-        <p:nvSpPr>
-          <p:cNvPr id="3" name="Subtitle 2">
-            <a:extLst>
-              <a:ext uri="{FF2B5EF4-FFF2-40B4-BE49-F238E27FC236}">
-                <a16:creationId xmlns:a16="http://schemas.microsoft.com/office/drawing/2014/main" id="{FD549426-1D11-FAB7-3571-B135365C8062}"/>
-              </a:ext>
-            </a:extLst>
-          </p:cNvPr>
-          <p:cNvSpPr>
-            <a:spLocks noGrp="1"/>
-          </p:cNvSpPr>
-          <p:nvPr>
-            <p:ph type="subTitle" idx="1"/>
-          </p:nvPr>
+            <a:pPr algn="ctr"/>
+            <a:r>
+              <a:rPr lang="en-GB" sz="2800" b="1" dirty="0">
+                <a:latin typeface="Aptos" panose="020B0004020202020204" pitchFamily="34" charset="0"/>
+              </a:rPr>
+              <a:t>Healthcare Analytics Pipeline for MediCare Hospital</a:t>
+            </a:r>
+          </a:p>
+          <a:p>
+            <a:pPr algn="ctr"/>
+            <a:r>
+              <a:rPr lang="en-GB" sz="2400" dirty="0"/>
+              <a:t>An End-to-End Scalable Data Engineering &amp; Analytics Platform</a:t>
+            </a:r>
+          </a:p>
+        </p:txBody>
+      </p:sp>
+      <p:sp>
+        <p:nvSpPr>
+          <p:cNvPr id="7" name="TextBox 6">
+            <a:extLst>
+              <a:ext uri="{FF2B5EF4-FFF2-40B4-BE49-F238E27FC236}">
+                <a16:creationId xmlns:a16="http://schemas.microsoft.com/office/drawing/2014/main" id="{17658355-7FE7-E36D-36A8-BF180493B854}"/>
+              </a:ext>
+            </a:extLst>
+          </p:cNvPr>
+          <p:cNvSpPr txBox="1"/>
+          <p:nvPr/>
         </p:nvSpPr>
         <p:spPr>
           <a:xfrm>
-            <a:off x="1386348" y="2310580"/>
-            <a:ext cx="9144000" cy="3880798"/>
+            <a:off x="599768" y="1905286"/>
+            <a:ext cx="6096000" cy="4647426"/>
           </a:xfrm>
+          <a:prstGeom prst="rect">
+            <a:avLst/>
+          </a:prstGeom>
+          <a:noFill/>
         </p:spPr>
         <p:txBody>
-          <a:bodyPr/>
+          <a:bodyPr wrap="square">
+            <a:spAutoFit/>
+          </a:bodyPr>
           <a:lstStyle/>
           <a:p>
-            <a:pPr algn="l"/>
             <a:r>
               <a:rPr lang="en-GB" sz="2000" b="1" dirty="0"/>
               <a:t>Capstone Project</a:t>
             </a:r>
           </a:p>
           <a:p>
-            <a:pPr algn="l"/>
-            <a:endParaRPr lang="en-GB" sz="2000" b="1" dirty="0"/>
-          </a:p>
-          <a:p>
-            <a:pPr algn="l"/>
-            <a:r>
-              <a:rPr lang="en-GB" dirty="0"/>
-              <a:t>Post Graduate Diploma in Data Engineering (PGDDE)</a:t>
-            </a:r>
-            <a:br>
-              <a:rPr lang="en-GB" dirty="0"/>
-            </a:br>
-            <a:r>
-              <a:rPr lang="en-GB" dirty="0"/>
-              <a:t>IIT Jodhpur</a:t>
-            </a:r>
-          </a:p>
-          <a:p>
-            <a:pPr algn="l"/>
-            <a:endParaRPr lang="en-GB" dirty="0"/>
-          </a:p>
-          <a:p>
-            <a:pPr algn="l"/>
+            <a:r>
+              <a:rPr lang="en-GB" sz="2000" b="1" dirty="0"/>
+              <a:t>Group Number: 3</a:t>
+            </a:r>
+          </a:p>
+          <a:p>
+            <a:endParaRPr lang="en-GB" sz="2000" dirty="0"/>
+          </a:p>
+          <a:p>
             <a:r>
               <a:rPr lang="en-GB" sz="2000" b="1" dirty="0"/>
               <a:t>Submitted By</a:t>
             </a:r>
           </a:p>
           <a:p>
-            <a:pPr algn="l"/>
-            <a:r>
-              <a:rPr lang="en-GB" sz="1800" dirty="0"/>
-              <a:t>Arpit Sharma (G25AI1012)</a:t>
-            </a:r>
-            <a:br>
-              <a:rPr lang="en-GB" sz="1800" dirty="0"/>
-            </a:br>
-            <a:r>
-              <a:rPr lang="en-GB" sz="1800" dirty="0"/>
-              <a:t>Ankita Dwivedi (G25AI1011)</a:t>
-            </a:r>
-            <a:br>
-              <a:rPr lang="en-GB" sz="1800" dirty="0"/>
-            </a:br>
-            <a:r>
-              <a:rPr lang="en-GB" sz="1800" dirty="0"/>
-              <a:t>Astosh Ranjan (G25AI1013)</a:t>
-            </a:r>
-            <a:br>
-              <a:rPr lang="en-GB" sz="1800" dirty="0"/>
-            </a:br>
-            <a:r>
-              <a:rPr lang="en-GB" sz="1800" dirty="0"/>
-              <a:t>Bharat Sharma (G25AI1014)</a:t>
-            </a:r>
-            <a:br>
-              <a:rPr lang="en-GB" sz="1800" dirty="0"/>
-            </a:br>
-            <a:r>
-              <a:rPr lang="en-GB" sz="1800" dirty="0"/>
-              <a:t>Damini Khatri (G25AI1015)</a:t>
-            </a:r>
-          </a:p>
-          <a:p>
-            <a:pPr algn="l"/>
             <a:endParaRPr lang="en-GB" dirty="0"/>
+          </a:p>
+          <a:p>
+            <a:r>
+              <a:rPr lang="en-GB" b="1" dirty="0"/>
+              <a:t>     Name                            Roll Number</a:t>
+            </a:r>
+          </a:p>
+          <a:p>
+            <a:pPr marL="285750" indent="-285750">
+              <a:buFont typeface="Wingdings" panose="05000000000000000000" pitchFamily="2" charset="2"/>
+              <a:buChar char="Ø"/>
+            </a:pPr>
+            <a:r>
+              <a:rPr lang="en-GB" dirty="0"/>
+              <a:t>Ankita Dwivedi            G25AI1011</a:t>
+            </a:r>
+          </a:p>
+          <a:p>
+            <a:pPr marL="285750" indent="-285750">
+              <a:buFont typeface="Wingdings" panose="05000000000000000000" pitchFamily="2" charset="2"/>
+              <a:buChar char="Ø"/>
+            </a:pPr>
+            <a:r>
+              <a:rPr lang="en-GB" dirty="0"/>
+              <a:t>Arpit Sharma               G25AI1012</a:t>
+            </a:r>
+          </a:p>
+          <a:p>
+            <a:pPr marL="285750" indent="-285750">
+              <a:buFont typeface="Wingdings" panose="05000000000000000000" pitchFamily="2" charset="2"/>
+              <a:buChar char="Ø"/>
+            </a:pPr>
+            <a:r>
+              <a:rPr lang="en-GB" dirty="0"/>
+              <a:t>Astosh Ranjan             G25AI1013</a:t>
+            </a:r>
+          </a:p>
+          <a:p>
+            <a:pPr marL="285750" indent="-285750">
+              <a:buFont typeface="Wingdings" panose="05000000000000000000" pitchFamily="2" charset="2"/>
+              <a:buChar char="Ø"/>
+            </a:pPr>
+            <a:r>
+              <a:rPr lang="en-GB" dirty="0"/>
+              <a:t>Bharat Sharma            G25AI1014</a:t>
+            </a:r>
+          </a:p>
+          <a:p>
+            <a:pPr marL="285750" indent="-285750">
+              <a:buFont typeface="Wingdings" panose="05000000000000000000" pitchFamily="2" charset="2"/>
+              <a:buChar char="Ø"/>
+            </a:pPr>
+            <a:r>
+              <a:rPr lang="en-GB" dirty="0"/>
+              <a:t>Damini Khatri              G25AI1015</a:t>
+            </a:r>
+          </a:p>
+          <a:p>
+            <a:endParaRPr lang="en-GB" dirty="0"/>
+          </a:p>
+          <a:p>
+            <a:endParaRPr lang="en-GB" dirty="0"/>
+          </a:p>
+          <a:p>
+            <a:r>
+              <a:rPr lang="en-GB" b="1" dirty="0"/>
+              <a:t>Post Graduate Diploma in Data Engineering (PGDDE)</a:t>
+            </a:r>
+          </a:p>
+          <a:p>
+            <a:r>
+              <a:rPr lang="en-GB" b="1" dirty="0"/>
+              <a:t>Indian Institute of Technology Jodhpur</a:t>
+            </a:r>
+          </a:p>
+          <a:p>
+            <a:r>
+              <a:rPr lang="en-GB" b="1" dirty="0"/>
+              <a:t>July 2026</a:t>
+            </a:r>
           </a:p>
         </p:txBody>
       </p:sp>
@@ -4751,10 +4785,10 @@
       </p:grpSpPr>
       <p:sp>
         <p:nvSpPr>
-          <p:cNvPr id="7" name="TextBox 6">
-            <a:extLst>
-              <a:ext uri="{FF2B5EF4-FFF2-40B4-BE49-F238E27FC236}">
-                <a16:creationId xmlns:a16="http://schemas.microsoft.com/office/drawing/2014/main" id="{02E96928-E3AF-658A-B9B5-615FA0379884}"/>
+          <p:cNvPr id="3" name="TextBox 2">
+            <a:extLst>
+              <a:ext uri="{FF2B5EF4-FFF2-40B4-BE49-F238E27FC236}">
+                <a16:creationId xmlns:a16="http://schemas.microsoft.com/office/drawing/2014/main" id="{A3876A29-32A1-E3DB-FCB8-13D27EFFB57D}"/>
               </a:ext>
             </a:extLst>
           </p:cNvPr>
@@ -4763,8 +4797,8 @@
         </p:nvSpPr>
         <p:spPr>
           <a:xfrm>
-            <a:off x="1081549" y="458956"/>
-            <a:ext cx="6096000" cy="6093976"/>
+            <a:off x="1071717" y="566678"/>
+            <a:ext cx="9635612" cy="4001095"/>
           </a:xfrm>
           <a:prstGeom prst="rect">
             <a:avLst/>
@@ -4777,113 +4811,445 @@
           </a:bodyPr>
           <a:lstStyle/>
           <a:p>
-            <a:r>
-              <a:rPr lang="en-GB" sz="3200" b="1" dirty="0"/>
-              <a:t>Conclusion &amp; Future Scope</a:t>
-            </a:r>
-          </a:p>
-          <a:p>
+            <a:pPr>
+              <a:buNone/>
+            </a:pPr>
+            <a:r>
+              <a:rPr lang="en-GB" sz="2800" b="1" dirty="0"/>
+              <a:t>Key Results Achieved</a:t>
+            </a:r>
+          </a:p>
+          <a:p>
+            <a:pPr>
+              <a:buNone/>
+            </a:pPr>
+            <a:endParaRPr lang="en-GB" sz="2800" b="1" dirty="0"/>
+          </a:p>
+          <a:p>
+            <a:pPr marL="285750" indent="-285750" algn="just">
+              <a:buFont typeface="Arial" panose="020B0604020202020204" pitchFamily="34" charset="0"/>
+              <a:buChar char="•"/>
+            </a:pPr>
+            <a:r>
+              <a:rPr lang="en-GB" dirty="0"/>
+              <a:t> Processed </a:t>
+            </a:r>
+            <a:r>
+              <a:rPr lang="en-GB" b="1" dirty="0"/>
+              <a:t>5000+ healthcare records</a:t>
+            </a:r>
+            <a:r>
+              <a:rPr lang="en-GB" dirty="0"/>
+              <a:t> through an end-to-end analytics pipeline.</a:t>
+            </a:r>
+          </a:p>
+          <a:p>
+            <a:pPr marL="285750" indent="-285750" algn="just">
+              <a:buFont typeface="Arial" panose="020B0604020202020204" pitchFamily="34" charset="0"/>
+              <a:buChar char="•"/>
+            </a:pPr>
+            <a:r>
+              <a:rPr lang="en-GB" dirty="0"/>
+              <a:t> Built a healthcare data engineering and analytics platform using AWS S3, PostgreSQL, </a:t>
+            </a:r>
+          </a:p>
+          <a:p>
+            <a:pPr algn="just"/>
+            <a:r>
+              <a:rPr lang="en-GB" dirty="0"/>
+              <a:t>       Airflow, PySpark, and Databricks.</a:t>
+            </a:r>
+          </a:p>
+          <a:p>
+            <a:pPr marL="285750" indent="-285750" algn="just">
+              <a:buFont typeface="Arial" panose="020B0604020202020204" pitchFamily="34" charset="0"/>
+              <a:buChar char="•"/>
+            </a:pPr>
+            <a:r>
+              <a:rPr lang="en-GB" dirty="0"/>
+              <a:t> Implemented </a:t>
+            </a:r>
+            <a:r>
+              <a:rPr lang="en-GB" b="1" dirty="0"/>
+              <a:t>real-time healthcare data streaming</a:t>
+            </a:r>
+            <a:r>
+              <a:rPr lang="en-GB" dirty="0"/>
+              <a:t> using Apache Kafka.</a:t>
+            </a:r>
+          </a:p>
+          <a:p>
+            <a:pPr marL="285750" indent="-285750" algn="just">
+              <a:buFont typeface="Arial" panose="020B0604020202020204" pitchFamily="34" charset="0"/>
+              <a:buChar char="•"/>
+            </a:pPr>
+            <a:r>
+              <a:rPr lang="en-GB" dirty="0"/>
+              <a:t> Developed an </a:t>
+            </a:r>
+            <a:r>
+              <a:rPr lang="en-GB" b="1" dirty="0"/>
+              <a:t>interactive Streamlit dashboard</a:t>
+            </a:r>
+            <a:r>
+              <a:rPr lang="en-GB" dirty="0"/>
+              <a:t> with dynamic filtering and KPI visualization.</a:t>
+            </a:r>
+          </a:p>
+          <a:p>
+            <a:pPr marL="285750" indent="-285750" algn="just">
+              <a:buFont typeface="Arial" panose="020B0604020202020204" pitchFamily="34" charset="0"/>
+              <a:buChar char="•"/>
+            </a:pPr>
+            <a:r>
+              <a:rPr lang="en-GB" dirty="0"/>
+              <a:t> Generated </a:t>
+            </a:r>
+            <a:r>
+              <a:rPr lang="en-GB" b="1" dirty="0"/>
+              <a:t>disease distribution, treatment cost, admission trends, and patient analytics</a:t>
+            </a:r>
+            <a:r>
+              <a:rPr lang="en-GB" dirty="0"/>
+              <a:t>.</a:t>
+            </a:r>
+          </a:p>
+          <a:p>
+            <a:pPr marL="285750" indent="-285750" algn="just">
+              <a:buFont typeface="Arial" panose="020B0604020202020204" pitchFamily="34" charset="0"/>
+              <a:buChar char="•"/>
+            </a:pPr>
+            <a:r>
+              <a:rPr lang="en-GB" dirty="0"/>
+              <a:t> Integrated </a:t>
+            </a:r>
+            <a:r>
+              <a:rPr lang="en-GB" b="1" dirty="0"/>
+              <a:t>Machine Learning (Random Forest)</a:t>
+            </a:r>
+            <a:r>
+              <a:rPr lang="en-GB" dirty="0"/>
+              <a:t> for predictive healthcare analytics.</a:t>
+            </a:r>
+          </a:p>
+          <a:p>
+            <a:pPr marL="285750" indent="-285750" algn="just">
+              <a:buFont typeface="Arial" panose="020B0604020202020204" pitchFamily="34" charset="0"/>
+              <a:buChar char="•"/>
+            </a:pPr>
+            <a:r>
+              <a:rPr lang="en-GB" dirty="0"/>
+              <a:t> Implemented </a:t>
+            </a:r>
+            <a:r>
+              <a:rPr lang="en-GB" b="1" dirty="0"/>
+              <a:t>GitHub Actions CI/CD automation</a:t>
+            </a:r>
+            <a:r>
+              <a:rPr lang="en-GB" dirty="0"/>
+              <a:t> for workflow validation and </a:t>
+            </a:r>
+          </a:p>
+          <a:p>
+            <a:pPr algn="just"/>
+            <a:r>
+              <a:rPr lang="en-GB" dirty="0"/>
+              <a:t>       deployment readiness.</a:t>
+            </a:r>
+          </a:p>
+          <a:p>
+            <a:pPr algn="just"/>
             <a:endParaRPr lang="en-GB" dirty="0"/>
           </a:p>
           <a:p>
-            <a:r>
-              <a:rPr lang="en-GB" sz="2000" dirty="0"/>
-              <a:t>• Built a complete Healthcare Analytics Pipeline.</a:t>
-            </a:r>
-          </a:p>
-          <a:p>
-            <a:r>
-              <a:rPr lang="en-GB" sz="2000" dirty="0"/>
-              <a:t>• </a:t>
-            </a:r>
-            <a:r>
-              <a:rPr lang="en-US" sz="2000" dirty="0"/>
-              <a:t>Integrated AWS S3, Apache Kafka, Databricks, </a:t>
-            </a:r>
-          </a:p>
-          <a:p>
-            <a:r>
-              <a:rPr lang="en-US" sz="2000" dirty="0"/>
-              <a:t>   Airflow, PySpark and PostgreSQL.</a:t>
-            </a:r>
-            <a:endParaRPr lang="en-GB" sz="2000" dirty="0"/>
-          </a:p>
-          <a:p>
-            <a:r>
-              <a:rPr lang="en-GB" sz="2000" dirty="0"/>
-              <a:t>• Designed a Star Schema Data Warehouse.</a:t>
-            </a:r>
-          </a:p>
-          <a:p>
-            <a:r>
-              <a:rPr lang="en-GB" sz="2000" dirty="0"/>
-              <a:t>• Developed an Interactive Streamlit Dashboard.</a:t>
-            </a:r>
-          </a:p>
-          <a:p>
-            <a:r>
-              <a:rPr lang="en-GB" sz="2000" dirty="0"/>
-              <a:t>• Implemented Machine Learning based Analytics.</a:t>
-            </a:r>
-          </a:p>
-          <a:p>
-            <a:r>
-              <a:rPr lang="en-US" sz="2000" dirty="0"/>
-              <a:t>• Implemented GitHub Actions based CI/CD workflow.</a:t>
-            </a:r>
-            <a:endParaRPr lang="en-GB" sz="2000" dirty="0"/>
-          </a:p>
-          <a:p>
+            <a:pPr>
+              <a:buNone/>
+            </a:pPr>
             <a:endParaRPr lang="en-GB" dirty="0"/>
           </a:p>
-          <a:p>
-            <a:r>
-              <a:rPr lang="en-GB" sz="3200" b="1" dirty="0"/>
-              <a:t>Future Scope</a:t>
-            </a:r>
-          </a:p>
-          <a:p>
-            <a:endParaRPr lang="en-GB" dirty="0"/>
-          </a:p>
-          <a:p>
-            <a:r>
-              <a:rPr lang="en-US" sz="2000" dirty="0"/>
-              <a:t>• Snowflake Data Warehouse integration</a:t>
-            </a:r>
-          </a:p>
-          <a:p>
-            <a:r>
-              <a:rPr lang="en-US" sz="2000" dirty="0"/>
-              <a:t>• Kubernetes-based container orchestration</a:t>
-            </a:r>
-          </a:p>
-          <a:p>
-            <a:r>
-              <a:rPr lang="en-US" sz="2000" dirty="0"/>
-              <a:t>• Advanced predictive analytics</a:t>
-            </a:r>
-          </a:p>
-          <a:p>
-            <a:r>
-              <a:rPr lang="en-US" sz="2000" dirty="0"/>
-              <a:t>• Integration with hospital information systems</a:t>
-            </a:r>
-          </a:p>
-          <a:p>
-            <a:endParaRPr lang="en-GB" sz="2000" dirty="0"/>
-          </a:p>
-          <a:p>
-            <a:r>
-              <a:rPr lang="en-GB" sz="3200" b="1" dirty="0"/>
-              <a:t>Thank You</a:t>
-            </a:r>
-          </a:p>
-        </p:txBody>
-      </p:sp>
+        </p:txBody>
+      </p:sp>
+      <p:pic>
+        <p:nvPicPr>
+          <p:cNvPr id="7" name="Picture 6">
+            <a:extLst>
+              <a:ext uri="{FF2B5EF4-FFF2-40B4-BE49-F238E27FC236}">
+                <a16:creationId xmlns:a16="http://schemas.microsoft.com/office/drawing/2014/main" id="{678D9886-49D7-7936-85ED-21E7D8A2DC09}"/>
+              </a:ext>
+            </a:extLst>
+          </p:cNvPr>
+          <p:cNvPicPr>
+            <a:picLocks noChangeAspect="1"/>
+          </p:cNvPicPr>
+          <p:nvPr/>
+        </p:nvPicPr>
+        <p:blipFill>
+          <a:blip r:embed="rId2">
+            <a:extLst>
+              <a:ext uri="{28A0092B-C50C-407E-A947-70E740481C1C}">
+                <a14:useLocalDpi xmlns:a14="http://schemas.microsoft.com/office/drawing/2010/main" val="0"/>
+              </a:ext>
+            </a:extLst>
+          </a:blip>
+          <a:srcRect/>
+          <a:stretch/>
+        </p:blipFill>
+        <p:spPr>
+          <a:xfrm>
+            <a:off x="845574" y="4365524"/>
+            <a:ext cx="5043949" cy="2158756"/>
+          </a:xfrm>
+          <a:prstGeom prst="rect">
+            <a:avLst/>
+          </a:prstGeom>
+        </p:spPr>
+      </p:pic>
+      <p:pic>
+        <p:nvPicPr>
+          <p:cNvPr id="9" name="Picture 8">
+            <a:extLst>
+              <a:ext uri="{FF2B5EF4-FFF2-40B4-BE49-F238E27FC236}">
+                <a16:creationId xmlns:a16="http://schemas.microsoft.com/office/drawing/2014/main" id="{3C39FDF8-0A37-9338-00E9-D0C94A2932DC}"/>
+              </a:ext>
+            </a:extLst>
+          </p:cNvPr>
+          <p:cNvPicPr>
+            <a:picLocks noChangeAspect="1"/>
+          </p:cNvPicPr>
+          <p:nvPr/>
+        </p:nvPicPr>
+        <p:blipFill>
+          <a:blip r:embed="rId3">
+            <a:extLst>
+              <a:ext uri="{28A0092B-C50C-407E-A947-70E740481C1C}">
+                <a14:useLocalDpi xmlns:a14="http://schemas.microsoft.com/office/drawing/2010/main" val="0"/>
+              </a:ext>
+            </a:extLst>
+          </a:blip>
+          <a:srcRect/>
+          <a:stretch/>
+        </p:blipFill>
+        <p:spPr>
+          <a:xfrm>
+            <a:off x="6449961" y="4365524"/>
+            <a:ext cx="5043949" cy="2158756"/>
+          </a:xfrm>
+          <a:prstGeom prst="rect">
+            <a:avLst/>
+          </a:prstGeom>
+        </p:spPr>
+      </p:pic>
     </p:spTree>
     <p:extLst>
       <p:ext uri="{BB962C8B-B14F-4D97-AF65-F5344CB8AC3E}">
-        <p14:creationId xmlns:p14="http://schemas.microsoft.com/office/powerpoint/2010/main" val="1636613480"/>
+        <p14:creationId xmlns:p14="http://schemas.microsoft.com/office/powerpoint/2010/main" val="1182394040"/>
+      </p:ext>
+    </p:extLst>
+  </p:cSld>
+  <p:clrMapOvr>
+    <a:masterClrMapping/>
+  </p:clrMapOvr>
+</p:sld>
+</file>
+
+<file path=ppt/slides/slide15.xml><?xml version="1.0" encoding="utf-8"?>
+<p:sld xmlns:a="http://schemas.openxmlformats.org/drawingml/2006/main" xmlns:r="http://schemas.openxmlformats.org/officeDocument/2006/relationships" xmlns:p="http://schemas.openxmlformats.org/presentationml/2006/main">
+  <p:cSld>
+    <p:spTree>
+      <p:nvGrpSpPr>
+        <p:cNvPr id="1" name=""/>
+        <p:cNvGrpSpPr/>
+        <p:nvPr/>
+      </p:nvGrpSpPr>
+      <p:grpSpPr>
+        <a:xfrm>
+          <a:off x="0" y="0"/>
+          <a:ext cx="0" cy="0"/>
+          <a:chOff x="0" y="0"/>
+          <a:chExt cx="0" cy="0"/>
+        </a:xfrm>
+      </p:grpSpPr>
+      <p:sp>
+        <p:nvSpPr>
+          <p:cNvPr id="3" name="TextBox 2">
+            <a:extLst>
+              <a:ext uri="{FF2B5EF4-FFF2-40B4-BE49-F238E27FC236}">
+                <a16:creationId xmlns:a16="http://schemas.microsoft.com/office/drawing/2014/main" id="{43A1AC31-2B9D-1AD1-06C6-B5C0D4B32E90}"/>
+              </a:ext>
+            </a:extLst>
+          </p:cNvPr>
+          <p:cNvSpPr txBox="1"/>
+          <p:nvPr/>
+        </p:nvSpPr>
+        <p:spPr>
+          <a:xfrm>
+            <a:off x="1081548" y="458956"/>
+            <a:ext cx="10363199" cy="6217087"/>
+          </a:xfrm>
+          <a:prstGeom prst="rect">
+            <a:avLst/>
+          </a:prstGeom>
+          <a:noFill/>
+        </p:spPr>
+        <p:txBody>
+          <a:bodyPr wrap="square">
+            <a:spAutoFit/>
+          </a:bodyPr>
+          <a:lstStyle/>
+          <a:p>
+            <a:r>
+              <a:rPr lang="en-GB" sz="3200" b="1" dirty="0"/>
+              <a:t>Conclusion</a:t>
+            </a:r>
+          </a:p>
+          <a:p>
+            <a:endParaRPr lang="en-GB" dirty="0"/>
+          </a:p>
+          <a:p>
+            <a:pPr marL="342900" indent="-342900">
+              <a:buFont typeface="Arial" panose="020B0604020202020204" pitchFamily="34" charset="0"/>
+              <a:buChar char="•"/>
+            </a:pPr>
+            <a:r>
+              <a:rPr lang="en-GB" sz="2000" dirty="0"/>
+              <a:t>Built a complete Healthcare Analytics Pipeline.</a:t>
+            </a:r>
+          </a:p>
+          <a:p>
+            <a:pPr marL="342900" indent="-342900">
+              <a:buFont typeface="Arial" panose="020B0604020202020204" pitchFamily="34" charset="0"/>
+              <a:buChar char="•"/>
+            </a:pPr>
+            <a:r>
+              <a:rPr lang="en-US" sz="2000" dirty="0"/>
+              <a:t>Integrated AWS S3, Apache Kafka, Databricks, Airflow, PySpark and PostgreSQL.</a:t>
+            </a:r>
+            <a:endParaRPr lang="en-GB" sz="2000" dirty="0"/>
+          </a:p>
+          <a:p>
+            <a:pPr marL="342900" indent="-342900">
+              <a:buFont typeface="Arial" panose="020B0604020202020204" pitchFamily="34" charset="0"/>
+              <a:buChar char="•"/>
+            </a:pPr>
+            <a:r>
+              <a:rPr lang="en-GB" sz="2000" dirty="0"/>
+              <a:t>Designed a Star Schema Data Warehouse.</a:t>
+            </a:r>
+          </a:p>
+          <a:p>
+            <a:pPr marL="342900" indent="-342900">
+              <a:buFont typeface="Arial" panose="020B0604020202020204" pitchFamily="34" charset="0"/>
+              <a:buChar char="•"/>
+            </a:pPr>
+            <a:r>
+              <a:rPr lang="en-GB" sz="2000" dirty="0"/>
+              <a:t>Developed an Interactive Streamlit Dashboard.</a:t>
+            </a:r>
+          </a:p>
+          <a:p>
+            <a:pPr marL="342900" indent="-342900">
+              <a:buFont typeface="Arial" panose="020B0604020202020204" pitchFamily="34" charset="0"/>
+              <a:buChar char="•"/>
+            </a:pPr>
+            <a:r>
+              <a:rPr lang="en-GB" sz="2000" dirty="0"/>
+              <a:t>Implemented Machine Learning based Analytics.</a:t>
+            </a:r>
+          </a:p>
+          <a:p>
+            <a:pPr marL="342900" indent="-342900">
+              <a:buFont typeface="Arial" panose="020B0604020202020204" pitchFamily="34" charset="0"/>
+              <a:buChar char="•"/>
+            </a:pPr>
+            <a:r>
+              <a:rPr lang="en-US" sz="2000" dirty="0"/>
+              <a:t>Implemented GitHub Actions based CI/CD workflow.</a:t>
+            </a:r>
+          </a:p>
+          <a:p>
+            <a:endParaRPr lang="en-US" sz="2000" dirty="0"/>
+          </a:p>
+          <a:p>
+            <a:r>
+              <a:rPr lang="en-GB" sz="3200" b="1" dirty="0"/>
+              <a:t>Future Scope</a:t>
+            </a:r>
+          </a:p>
+          <a:p>
+            <a:endParaRPr lang="en-US" sz="2000" dirty="0"/>
+          </a:p>
+          <a:p>
+            <a:pPr marL="342900" indent="-342900">
+              <a:buFont typeface="Arial" panose="020B0604020202020204" pitchFamily="34" charset="0"/>
+              <a:buChar char="•"/>
+            </a:pPr>
+            <a:r>
+              <a:rPr lang="en-US" sz="2000" dirty="0"/>
+              <a:t>Snowflake Data Warehouse Integration.</a:t>
+            </a:r>
+          </a:p>
+          <a:p>
+            <a:pPr marL="342900" indent="-342900">
+              <a:buFont typeface="Arial" panose="020B0604020202020204" pitchFamily="34" charset="0"/>
+              <a:buChar char="•"/>
+            </a:pPr>
+            <a:r>
+              <a:rPr lang="en-US" sz="2000" dirty="0"/>
+              <a:t>Kubernetes-based Container Orchestration.</a:t>
+            </a:r>
+          </a:p>
+          <a:p>
+            <a:pPr marL="342900" indent="-342900">
+              <a:buFont typeface="Arial" panose="020B0604020202020204" pitchFamily="34" charset="0"/>
+              <a:buChar char="•"/>
+            </a:pPr>
+            <a:r>
+              <a:rPr lang="en-US" sz="2000" dirty="0"/>
+              <a:t>Production-grade Apache Kafka Streaming.</a:t>
+            </a:r>
+          </a:p>
+          <a:p>
+            <a:pPr marL="342900" indent="-342900">
+              <a:buFont typeface="Arial" panose="020B0604020202020204" pitchFamily="34" charset="0"/>
+              <a:buChar char="•"/>
+            </a:pPr>
+            <a:r>
+              <a:rPr lang="en-US" sz="2000" dirty="0"/>
+              <a:t>Integration with Hospital Information Systems.</a:t>
+            </a:r>
+          </a:p>
+          <a:p>
+            <a:pPr marL="342900" indent="-342900">
+              <a:buFont typeface="Arial" panose="020B0604020202020204" pitchFamily="34" charset="0"/>
+              <a:buChar char="•"/>
+            </a:pPr>
+            <a:r>
+              <a:rPr lang="en-US" sz="2000" dirty="0"/>
+              <a:t>Advanced Predictive Analytics &amp; Real-time Alerts.</a:t>
+            </a:r>
+            <a:endParaRPr lang="en-GB" sz="2000" dirty="0"/>
+          </a:p>
+          <a:p>
+            <a:pPr algn="ctr"/>
+            <a:r>
+              <a:rPr lang="en-GB" sz="2800" b="1" dirty="0"/>
+              <a:t>                                                    </a:t>
+            </a:r>
+          </a:p>
+          <a:p>
+            <a:pPr algn="ctr"/>
+            <a:r>
+              <a:rPr lang="en-GB" sz="2800" b="1" dirty="0"/>
+              <a:t>Thank You!                                                    </a:t>
+            </a:r>
+            <a:endParaRPr lang="en-GB" sz="2000" dirty="0"/>
+          </a:p>
+        </p:txBody>
+      </p:sp>
+    </p:spTree>
+    <p:extLst>
+      <p:ext uri="{BB962C8B-B14F-4D97-AF65-F5344CB8AC3E}">
+        <p14:creationId xmlns:p14="http://schemas.microsoft.com/office/powerpoint/2010/main" val="2838295901"/>
       </p:ext>
     </p:extLst>
   </p:cSld>
@@ -4924,8 +5290,8 @@
         </p:nvSpPr>
         <p:spPr>
           <a:xfrm>
-            <a:off x="855407" y="792350"/>
-            <a:ext cx="10245213" cy="5078313"/>
+            <a:off x="973393" y="26641"/>
+            <a:ext cx="10245213" cy="7171194"/>
           </a:xfrm>
           <a:prstGeom prst="rect">
             <a:avLst/>
@@ -4944,7 +5310,7 @@
             </a:r>
           </a:p>
           <a:p>
-            <a:endParaRPr lang="en-GB" sz="2400" dirty="0"/>
+            <a:endParaRPr lang="en-GB" sz="1200" dirty="0"/>
           </a:p>
           <a:p>
             <a:r>
@@ -4977,7 +5343,7 @@
             </a:r>
           </a:p>
           <a:p>
-            <a:endParaRPr lang="en-GB" sz="2400" dirty="0"/>
+            <a:endParaRPr lang="en-GB" sz="1400" dirty="0"/>
           </a:p>
           <a:p>
             <a:r>
@@ -4986,7 +5352,7 @@
             </a:r>
           </a:p>
           <a:p>
-            <a:endParaRPr lang="en-GB" sz="3200" dirty="0"/>
+            <a:endParaRPr lang="en-GB" sz="1200" dirty="0"/>
           </a:p>
           <a:p>
             <a:r>
@@ -5012,8 +5378,72 @@
             </a:br>
             <a:r>
               <a:rPr lang="en-GB" sz="2000" dirty="0"/>
-              <a:t>• Enable scalable and cloud-based healthcare analytics.</a:t>
-            </a:r>
+              <a:t>• Enable scalable healthcare analytics by leveraging cloud services.</a:t>
+            </a:r>
+          </a:p>
+          <a:p>
+            <a:endParaRPr lang="en-GB" sz="1400" dirty="0"/>
+          </a:p>
+          <a:p>
+            <a:r>
+              <a:rPr lang="en-US" sz="3200" b="1" dirty="0"/>
+              <a:t>Project Resources</a:t>
+            </a:r>
+          </a:p>
+          <a:p>
+            <a:endParaRPr lang="en-US" sz="1200" dirty="0"/>
+          </a:p>
+          <a:p>
+            <a:r>
+              <a:rPr lang="en-US" sz="2000" dirty="0"/>
+              <a:t>• </a:t>
+            </a:r>
+            <a:r>
+              <a:rPr lang="en-US" sz="2000" b="1" dirty="0"/>
+              <a:t>GitHub Repository:</a:t>
+            </a:r>
+          </a:p>
+          <a:p>
+            <a:r>
+              <a:rPr lang="en-US" sz="2000" dirty="0"/>
+              <a:t>  </a:t>
+            </a:r>
+            <a:r>
+              <a:rPr lang="en-US" sz="2000" dirty="0">
+                <a:hlinkClick r:id="rId2"/>
+              </a:rPr>
+              <a:t>https://github.com/arpit-systems/healthcare-analytics-pipeline</a:t>
+            </a:r>
+            <a:endParaRPr lang="en-US" sz="2000" dirty="0"/>
+          </a:p>
+          <a:p>
+            <a:endParaRPr lang="en-US" sz="2000" dirty="0"/>
+          </a:p>
+          <a:p>
+            <a:r>
+              <a:rPr lang="en-US" sz="2000" dirty="0"/>
+              <a:t>• </a:t>
+            </a:r>
+            <a:r>
+              <a:rPr lang="en-US" sz="2000" b="1" dirty="0"/>
+              <a:t>Final Project Report:</a:t>
+            </a:r>
+          </a:p>
+          <a:p>
+            <a:r>
+              <a:rPr lang="en-GB" sz="2000" dirty="0"/>
+              <a:t> </a:t>
+            </a:r>
+            <a:r>
+              <a:rPr lang="en-GB" sz="2000" dirty="0">
+                <a:hlinkClick r:id="rId3"/>
+              </a:rPr>
+              <a:t>https://drive.google.com/file/d/178q8gNesaShG-yQghYCeDS8-bwI6Nsow/view?usp=sharing</a:t>
+            </a:r>
+            <a:endParaRPr lang="en-GB" sz="2000" dirty="0"/>
+          </a:p>
+          <a:p>
+            <a:endParaRPr lang="en-GB" sz="2000" dirty="0"/>
           </a:p>
         </p:txBody>
       </p:sp>
@@ -5086,7 +5516,11 @@
           <a:p>
             <a:r>
               <a:rPr lang="en-US" sz="2000" dirty="0"/>
-              <a:t>• Cloud-based end-to-end analytics pipeline</a:t>
+              <a:t>• </a:t>
+            </a:r>
+            <a:r>
+              <a:rPr lang="en-GB" sz="2000" dirty="0"/>
+              <a:t>Integrated Healthcare Data Engineering Architecture</a:t>
             </a:r>
           </a:p>
           <a:p>
@@ -5156,14 +5590,13 @@
               </a:ext>
             </a:extLst>
           </a:blip>
-          <a:stretch>
-            <a:fillRect/>
-          </a:stretch>
+          <a:srcRect/>
+          <a:stretch/>
         </p:blipFill>
         <p:spPr>
           <a:xfrm>
-            <a:off x="380999" y="167148"/>
-            <a:ext cx="5538020" cy="6449962"/>
+            <a:off x="569104" y="167148"/>
+            <a:ext cx="5161809" cy="6449962"/>
           </a:xfrm>
           <a:prstGeom prst="rect">
             <a:avLst/>

</xml_diff>

<commit_message>
Add final presentation and project report
Uploaded the final capstone presentation slides and project report.

Updated the documentation with the latest submission-ready deliverables for the Healthcare Analytics Pipeline project, including the final presentation and report.
</commit_message>
<xml_diff>
--- a/docs/docs/PGDDE_Capstone_Healthcare_Analytics_Pipeline_IITJ.pptx
+++ b/docs/docs/PGDDE_Capstone_Healthcare_Analytics_Pipeline_IITJ.pptx
@@ -5291,7 +5291,7 @@
         <p:spPr>
           <a:xfrm>
             <a:off x="973393" y="26641"/>
-            <a:ext cx="10245213" cy="7171194"/>
+            <a:ext cx="10245213" cy="6863417"/>
           </a:xfrm>
           <a:prstGeom prst="rect">
             <a:avLst/>
@@ -5417,9 +5417,6 @@
             <a:endParaRPr lang="en-US" sz="2000" dirty="0"/>
           </a:p>
           <a:p>
-            <a:endParaRPr lang="en-US" sz="2000" dirty="0"/>
-          </a:p>
-          <a:p>
             <a:r>
               <a:rPr lang="en-US" sz="2000" dirty="0"/>
               <a:t>• </a:t>
@@ -5438,7 +5435,7 @@
               <a:rPr lang="en-GB" sz="2000" dirty="0">
                 <a:hlinkClick r:id="rId3"/>
               </a:rPr>
-              <a:t>https://drive.google.com/file/d/178q8gNesaShG-yQghYCeDS8-bwI6Nsow/view?usp=sharing</a:t>
+              <a:t>https://drive.google.com/file/d/1gJPl8zC-l_vYn_bC0B9SGhOb3Uhrsf_k/view?usp=sharing</a:t>
             </a:r>
             <a:endParaRPr lang="en-GB" sz="2000" dirty="0"/>
           </a:p>
@@ -5835,7 +5832,7 @@
         </p:nvSpPr>
         <p:spPr>
           <a:xfrm>
-            <a:off x="6902246" y="3742526"/>
+            <a:off x="7079226" y="3737693"/>
             <a:ext cx="5034115" cy="2893100"/>
           </a:xfrm>
           <a:prstGeom prst="rect">

</xml_diff>